<commit_message>
Cache Controller Project Verilog
</commit_message>
<xml_diff>
--- a/Cache_Controller_Presentation.pptx
+++ b/Cache_Controller_Presentation.pptx
@@ -4,6 +4,9 @@
   <p:sldMasterIdLst>
     <p:sldMasterId id="2147483648" r:id="rId1"/>
   </p:sldMasterIdLst>
+  <p:notesMasterIdLst>
+    <p:notesMasterId r:id="rId14"/>
+  </p:notesMasterIdLst>
   <p:sldIdLst>
     <p:sldId id="256" r:id="rId2"/>
     <p:sldId id="257" r:id="rId3"/>
@@ -18,9 +21,6 @@
     <p:sldId id="266" r:id="rId12"/>
     <p:sldId id="267" r:id="rId13"/>
   </p:sldIdLst>
-  <p:notesMasterIdLst>
-    <p:notesMasterId r:id="rId14"/>
-  </p:notesMasterIdLst>
   <p:sldSz cx="12192000" cy="6858000"/>
   <p:notesSz cx="6858000" cy="12192000"/>
   <p:defaultTextStyle>
@@ -115,6 +115,11 @@
       </a:defRPr>
     </a:lvl9pPr>
   </p:defaultTextStyle>
+  <p:extLst>
+    <p:ext uri="{EFAFB233-063F-42B5-8137-9DF3F51BA10A}">
+      <p15:sldGuideLst xmlns:p15="http://schemas.microsoft.com/office/powerpoint/2012/main"/>
+    </p:ext>
+  </p:extLst>
 </p:presentation>
 </file>
 
@@ -140,234 +145,10 @@
           <a:chExt cx="0" cy="0"/>
         </a:xfrm>
       </p:grpSpPr>
-      <p:sp>
-        <p:nvSpPr>
-          <p:cNvPr id="2" name="Header Placeholder 1"/>
-          <p:cNvSpPr>
-            <a:spLocks noGrp="1"/>
-          </p:cNvSpPr>
-          <p:nvPr>
-            <p:ph type="hdr" sz="quarter"/>
-          </p:nvPr>
-        </p:nvSpPr>
-        <p:spPr>
-          <a:xfrm>
-            <a:off x="0" y="0"/>
-            <a:ext cx="2971800" cy="458788"/>
-          </a:xfrm>
-          <a:prstGeom prst="rect">
-            <a:avLst/>
-          </a:prstGeom>
-        </p:spPr>
-        <p:txBody>
-          <a:bodyPr vert="horz" lIns="91440" tIns="45720" rIns="91440" bIns="45720" rtlCol="0"/>
-          <a:lstStyle>
-            <a:lvl1pPr algn="l">
-              <a:defRPr sz="1200"/>
-            </a:lvl1pPr>
-          </a:lstStyle>
-          <a:p>
-            <a:endParaRPr lang="en-US"/>
-          </a:p>
-        </p:txBody>
-      </p:sp>
-      <p:sp>
-        <p:nvSpPr>
-          <p:cNvPr id="3" name="Date Placeholder 2"/>
-          <p:cNvSpPr>
-            <a:spLocks noGrp="1"/>
-          </p:cNvSpPr>
-          <p:nvPr>
-            <p:ph type="dt" idx="1"/>
-          </p:nvPr>
-        </p:nvSpPr>
-        <p:spPr>
-          <a:xfrm>
-            <a:off x="3884613" y="0"/>
-            <a:ext cx="2971800" cy="458788"/>
-          </a:xfrm>
-          <a:prstGeom prst="rect">
-            <a:avLst/>
-          </a:prstGeom>
-        </p:spPr>
-        <p:txBody>
-          <a:bodyPr vert="horz" lIns="91440" tIns="45720" rIns="91440" bIns="45720" rtlCol="0"/>
-          <a:lstStyle>
-            <a:lvl1pPr algn="r">
-              <a:defRPr sz="1200"/>
-            </a:lvl1pPr>
-          </a:lstStyle>
-          <a:p>
-            <a:fld id="{5282F153-3F37-0F45-9E97-73ACFA13230C}" type="datetimeFigureOut">
-              <a:rPr lang="en-US"/>
-              <a:t>7/23/19</a:t>
-            </a:fld>
-            <a:endParaRPr lang="en-US"/>
-          </a:p>
-        </p:txBody>
-      </p:sp>
-      <p:sp>
-        <p:nvSpPr>
-          <p:cNvPr id="4" name="Slide Image Placeholder 3"/>
-          <p:cNvSpPr>
-            <a:spLocks noGrp="1" noRot="1" noChangeAspect="1"/>
-          </p:cNvSpPr>
-          <p:nvPr>
-            <p:ph type="sldImg" idx="2"/>
-          </p:nvPr>
-        </p:nvSpPr>
-        <p:spPr>
-          <a:xfrm>
-            <a:off x="685800" y="1143000"/>
-            <a:ext cx="5486400" cy="3086100"/>
-          </a:xfrm>
-          <a:prstGeom prst="rect">
-            <a:avLst/>
-          </a:prstGeom>
-          <a:noFill/>
-          <a:ln w="12700">
-            <a:solidFill>
-              <a:prstClr val="black"/>
-            </a:solidFill>
-          </a:ln>
-        </p:spPr>
-        <p:txBody>
-          <a:bodyPr vert="horz" lIns="91440" tIns="45720" rIns="91440" bIns="45720" rtlCol="0" anchor="ctr"/>
-          <a:lstStyle/>
-          <a:p>
-            <a:endParaRPr lang="en-US"/>
-          </a:p>
-        </p:txBody>
-      </p:sp>
-      <p:sp>
-        <p:nvSpPr>
-          <p:cNvPr id="5" name="Notes Placeholder 4"/>
-          <p:cNvSpPr>
-            <a:spLocks noGrp="1"/>
-          </p:cNvSpPr>
-          <p:nvPr>
-            <p:ph type="body" sz="quarter" idx="3"/>
-          </p:nvPr>
-        </p:nvSpPr>
-        <p:spPr>
-          <a:xfrm>
-            <a:off x="685800" y="4400550"/>
-            <a:ext cx="5486400" cy="3600450"/>
-          </a:xfrm>
-          <a:prstGeom prst="rect">
-            <a:avLst/>
-          </a:prstGeom>
-        </p:spPr>
-        <p:txBody>
-          <a:bodyPr vert="horz" lIns="91440" tIns="45720" rIns="91440" bIns="45720" rtlCol="0"/>
-          <a:lstStyle/>
-          <a:p>
-            <a:pPr lvl="0"/>
-            <a:r>
-              <a:rPr lang="en-US"/>
-              <a:t>Click to edit Master text styles</a:t>
-            </a:r>
-          </a:p>
-          <a:p>
-            <a:pPr lvl="1"/>
-            <a:r>
-              <a:rPr lang="en-US"/>
-              <a:t>Second level</a:t>
-            </a:r>
-          </a:p>
-          <a:p>
-            <a:pPr lvl="2"/>
-            <a:r>
-              <a:rPr lang="en-US"/>
-              <a:t>Third level</a:t>
-            </a:r>
-          </a:p>
-          <a:p>
-            <a:pPr lvl="3"/>
-            <a:r>
-              <a:rPr lang="en-US"/>
-              <a:t>Fourth level</a:t>
-            </a:r>
-          </a:p>
-          <a:p>
-            <a:pPr lvl="4"/>
-            <a:r>
-              <a:rPr lang="en-US"/>
-              <a:t>Fifth level</a:t>
-            </a:r>
-          </a:p>
-        </p:txBody>
-      </p:sp>
-      <p:sp>
-        <p:nvSpPr>
-          <p:cNvPr id="6" name="Footer Placeholder 5"/>
-          <p:cNvSpPr>
-            <a:spLocks noGrp="1"/>
-          </p:cNvSpPr>
-          <p:nvPr>
-            <p:ph type="ftr" sz="quarter" idx="4"/>
-          </p:nvPr>
-        </p:nvSpPr>
-        <p:spPr>
-          <a:xfrm>
-            <a:off x="0" y="8685213"/>
-            <a:ext cx="2971800" cy="458787"/>
-          </a:xfrm>
-          <a:prstGeom prst="rect">
-            <a:avLst/>
-          </a:prstGeom>
-        </p:spPr>
-        <p:txBody>
-          <a:bodyPr vert="horz" lIns="91440" tIns="45720" rIns="91440" bIns="45720" rtlCol="0" anchor="b"/>
-          <a:lstStyle>
-            <a:lvl1pPr algn="l">
-              <a:defRPr sz="1200"/>
-            </a:lvl1pPr>
-          </a:lstStyle>
-          <a:p>
-            <a:endParaRPr lang="en-US"/>
-          </a:p>
-        </p:txBody>
-      </p:sp>
-      <p:sp>
-        <p:nvSpPr>
-          <p:cNvPr id="7" name="Slide Number Placeholder 6"/>
-          <p:cNvSpPr>
-            <a:spLocks noGrp="1"/>
-          </p:cNvSpPr>
-          <p:nvPr>
-            <p:ph type="sldNum" sz="quarter" idx="5"/>
-          </p:nvPr>
-        </p:nvSpPr>
-        <p:spPr>
-          <a:xfrm>
-            <a:off x="3884613" y="8685213"/>
-            <a:ext cx="2971800" cy="458787"/>
-          </a:xfrm>
-          <a:prstGeom prst="rect">
-            <a:avLst/>
-          </a:prstGeom>
-        </p:spPr>
-        <p:txBody>
-          <a:bodyPr vert="horz" lIns="91440" tIns="45720" rIns="91440" bIns="45720" rtlCol="0" anchor="b"/>
-          <a:lstStyle>
-            <a:lvl1pPr algn="r">
-              <a:defRPr sz="1200"/>
-            </a:lvl1pPr>
-          </a:lstStyle>
-          <a:p>
-            <a:fld id="{CE5E9CC1-C706-0F49-92D6-E571CC5EEA8F}" type="slidenum">
-              <a:rPr lang="en-US"/>
-              <a:t>‹#›</a:t>
-            </a:fld>
-            <a:endParaRPr lang="en-US"/>
-          </a:p>
-        </p:txBody>
-      </p:sp>
     </p:spTree>
     <p:extLst>
       <p:ext uri="{BB962C8B-B14F-4D97-AF65-F5344CB8AC3E}">
-        <p14:creationId xmlns:p14="http://schemas.microsoft.com/office/powerpoint/2010/main" val="1024086991"/>
+        <p14:creationId xmlns:p14="http://schemas.microsoft.com/office/powerpoint/2010/main" val="31969112"/>
       </p:ext>
     </p:extLst>
   </p:cSld>
@@ -511,10 +292,6 @@
           <a:bodyPr/>
           <a:lstStyle/>
           <a:p>
-            <a:r>
-              <a:rPr lang="en-US" dirty="0"/>
-              <a:t/>
-            </a:r>
             <a:endParaRPr lang="en-US" dirty="0"/>
           </a:p>
         </p:txBody>
@@ -599,10 +376,6 @@
           <a:bodyPr/>
           <a:lstStyle/>
           <a:p>
-            <a:r>
-              <a:rPr lang="en-US" dirty="0"/>
-              <a:t/>
-            </a:r>
             <a:endParaRPr lang="en-US" dirty="0"/>
           </a:p>
         </p:txBody>
@@ -687,10 +460,6 @@
           <a:bodyPr/>
           <a:lstStyle/>
           <a:p>
-            <a:r>
-              <a:rPr lang="en-US" dirty="0"/>
-              <a:t/>
-            </a:r>
             <a:endParaRPr lang="en-US" dirty="0"/>
           </a:p>
         </p:txBody>
@@ -775,10 +544,6 @@
           <a:bodyPr/>
           <a:lstStyle/>
           <a:p>
-            <a:r>
-              <a:rPr lang="en-US" dirty="0"/>
-              <a:t/>
-            </a:r>
             <a:endParaRPr lang="en-US" dirty="0"/>
           </a:p>
         </p:txBody>
@@ -863,10 +628,6 @@
           <a:bodyPr/>
           <a:lstStyle/>
           <a:p>
-            <a:r>
-              <a:rPr lang="en-US" dirty="0"/>
-              <a:t/>
-            </a:r>
             <a:endParaRPr lang="en-US" dirty="0"/>
           </a:p>
         </p:txBody>
@@ -951,10 +712,6 @@
           <a:bodyPr/>
           <a:lstStyle/>
           <a:p>
-            <a:r>
-              <a:rPr lang="en-US" dirty="0"/>
-              <a:t/>
-            </a:r>
             <a:endParaRPr lang="en-US" dirty="0"/>
           </a:p>
         </p:txBody>
@@ -1039,10 +796,6 @@
           <a:bodyPr/>
           <a:lstStyle/>
           <a:p>
-            <a:r>
-              <a:rPr lang="en-US" dirty="0"/>
-              <a:t/>
-            </a:r>
             <a:endParaRPr lang="en-US" dirty="0"/>
           </a:p>
         </p:txBody>
@@ -1127,10 +880,6 @@
           <a:bodyPr/>
           <a:lstStyle/>
           <a:p>
-            <a:r>
-              <a:rPr lang="en-US" dirty="0"/>
-              <a:t/>
-            </a:r>
             <a:endParaRPr lang="en-US" dirty="0"/>
           </a:p>
         </p:txBody>
@@ -1215,10 +964,6 @@
           <a:bodyPr/>
           <a:lstStyle/>
           <a:p>
-            <a:r>
-              <a:rPr lang="en-US" dirty="0"/>
-              <a:t/>
-            </a:r>
             <a:endParaRPr lang="en-US" dirty="0"/>
           </a:p>
         </p:txBody>
@@ -1303,10 +1048,6 @@
           <a:bodyPr/>
           <a:lstStyle/>
           <a:p>
-            <a:r>
-              <a:rPr lang="en-US" dirty="0"/>
-              <a:t/>
-            </a:r>
             <a:endParaRPr lang="en-US" dirty="0"/>
           </a:p>
         </p:txBody>
@@ -1391,10 +1132,6 @@
           <a:bodyPr/>
           <a:lstStyle/>
           <a:p>
-            <a:r>
-              <a:rPr lang="en-US" dirty="0"/>
-              <a:t/>
-            </a:r>
             <a:endParaRPr lang="en-US" dirty="0"/>
           </a:p>
         </p:txBody>
@@ -1479,10 +1216,6 @@
           <a:bodyPr/>
           <a:lstStyle/>
           <a:p>
-            <a:r>
-              <a:rPr lang="en-US" dirty="0"/>
-              <a:t/>
-            </a:r>
             <a:endParaRPr lang="en-US" dirty="0"/>
           </a:p>
         </p:txBody>
@@ -1556,6 +1289,11 @@
 <file path=ppt/slideMasters/slideMaster1.xml><?xml version="1.0" encoding="utf-8"?>
 <p:sldMaster xmlns:a="http://schemas.openxmlformats.org/drawingml/2006/main" xmlns:r="http://schemas.openxmlformats.org/officeDocument/2006/relationships" xmlns:p="http://schemas.openxmlformats.org/presentationml/2006/main">
   <p:cSld>
+    <p:bg>
+      <p:bgRef idx="1001">
+        <a:schemeClr val="bg1"/>
+      </p:bgRef>
+    </p:bg>
     <p:spTree>
       <p:nvGrpSpPr>
         <p:cNvPr id="1" name=""/>
@@ -1838,6 +1576,7 @@
         <a:solidFill>
           <a:srgbClr val="FFFFFF"/>
         </a:solidFill>
+        <a:effectLst/>
       </p:bgPr>
     </p:bg>
     <p:spTree>
@@ -1878,6 +1617,13 @@
             <a:prstDash val="solid"/>
           </a:ln>
         </p:spPr>
+        <p:txBody>
+          <a:bodyPr/>
+          <a:lstStyle/>
+          <a:p>
+            <a:endParaRPr lang="en-US"/>
+          </a:p>
+        </p:txBody>
       </p:sp>
       <p:sp>
         <p:nvSpPr>
@@ -1905,6 +1651,13 @@
             <a:prstDash val="solid"/>
           </a:ln>
         </p:spPr>
+        <p:txBody>
+          <a:bodyPr/>
+          <a:lstStyle/>
+          <a:p>
+            <a:endParaRPr lang="en-US"/>
+          </a:p>
+        </p:txBody>
       </p:sp>
       <p:sp>
         <p:nvSpPr>
@@ -1929,7 +1682,7 @@
           </a:bodyPr>
           <a:lstStyle/>
           <a:p>
-            <a:pPr indent="0" marL="0">
+            <a:pPr marL="0" indent="0">
               <a:buNone/>
             </a:pPr>
             <a:r>
@@ -1946,7 +1699,7 @@
             <a:endParaRPr lang="en-US" sz="3400" dirty="0"/>
           </a:p>
           <a:p>
-            <a:pPr indent="0" marL="0">
+            <a:pPr marL="0" indent="0">
               <a:buNone/>
             </a:pPr>
             <a:r>
@@ -1985,7 +1738,7 @@
           <a:bodyPr wrap="square" lIns="0" tIns="0" rIns="0" bIns="0" rtlCol="0" anchor="ctr"/>
           <a:lstStyle/>
           <a:p>
-            <a:pPr indent="0" marL="0">
+            <a:pPr marL="0" indent="0">
               <a:buNone/>
             </a:pPr>
             <a:r>
@@ -2022,6 +1775,13 @@
             <a:prstDash val="solid"/>
           </a:ln>
         </p:spPr>
+        <p:txBody>
+          <a:bodyPr/>
+          <a:lstStyle/>
+          <a:p>
+            <a:endParaRPr lang="en-US"/>
+          </a:p>
+        </p:txBody>
       </p:sp>
       <p:sp>
         <p:nvSpPr>
@@ -2044,7 +1804,7 @@
           <a:bodyPr wrap="square" lIns="0" tIns="0" rIns="0" bIns="0" rtlCol="0" anchor="ctr"/>
           <a:lstStyle/>
           <a:p>
-            <a:pPr indent="0" marL="0">
+            <a:pPr marL="0" indent="0">
               <a:buNone/>
             </a:pPr>
             <a:r>
@@ -2085,6 +1845,13 @@
             <a:prstDash val="solid"/>
           </a:ln>
         </p:spPr>
+        <p:txBody>
+          <a:bodyPr/>
+          <a:lstStyle/>
+          <a:p>
+            <a:endParaRPr lang="en-US"/>
+          </a:p>
+        </p:txBody>
       </p:sp>
       <p:sp>
         <p:nvSpPr>
@@ -2107,7 +1874,7 @@
           <a:bodyPr wrap="square" lIns="0" tIns="0" rIns="0" bIns="0" rtlCol="0" anchor="ctr"/>
           <a:lstStyle/>
           <a:p>
-            <a:pPr algn="ctr" indent="0" marL="0">
+            <a:pPr marL="0" indent="0" algn="ctr">
               <a:buNone/>
             </a:pPr>
             <a:r>
@@ -2146,6 +1913,13 @@
             <a:tailEnd type="triangle"/>
           </a:ln>
         </p:spPr>
+        <p:txBody>
+          <a:bodyPr/>
+          <a:lstStyle/>
+          <a:p>
+            <a:endParaRPr lang="en-US"/>
+          </a:p>
+        </p:txBody>
       </p:sp>
       <p:sp>
         <p:nvSpPr>
@@ -2173,6 +1947,13 @@
             <a:prstDash val="solid"/>
           </a:ln>
         </p:spPr>
+        <p:txBody>
+          <a:bodyPr/>
+          <a:lstStyle/>
+          <a:p>
+            <a:endParaRPr lang="en-US"/>
+          </a:p>
+        </p:txBody>
       </p:sp>
       <p:sp>
         <p:nvSpPr>
@@ -2195,7 +1976,7 @@
           <a:bodyPr wrap="square" lIns="0" tIns="0" rIns="0" bIns="0" rtlCol="0" anchor="ctr"/>
           <a:lstStyle/>
           <a:p>
-            <a:pPr algn="ctr" indent="0" marL="0">
+            <a:pPr marL="0" indent="0" algn="ctr">
               <a:buNone/>
             </a:pPr>
             <a:r>
@@ -2209,7 +1990,7 @@
             <a:endParaRPr lang="en-US" sz="1400" dirty="0"/>
           </a:p>
           <a:p>
-            <a:pPr algn="ctr" indent="0" marL="0">
+            <a:pPr marL="0" indent="0" algn="ctr">
               <a:buNone/>
             </a:pPr>
             <a:r>
@@ -2248,6 +2029,13 @@
             <a:tailEnd type="triangle"/>
           </a:ln>
         </p:spPr>
+        <p:txBody>
+          <a:bodyPr/>
+          <a:lstStyle/>
+          <a:p>
+            <a:endParaRPr lang="en-US"/>
+          </a:p>
+        </p:txBody>
       </p:sp>
       <p:sp>
         <p:nvSpPr>
@@ -2275,6 +2063,13 @@
             <a:prstDash val="solid"/>
           </a:ln>
         </p:spPr>
+        <p:txBody>
+          <a:bodyPr/>
+          <a:lstStyle/>
+          <a:p>
+            <a:endParaRPr lang="en-US"/>
+          </a:p>
+        </p:txBody>
       </p:sp>
       <p:sp>
         <p:nvSpPr>
@@ -2297,7 +2092,7 @@
           <a:bodyPr wrap="square" lIns="0" tIns="0" rIns="0" bIns="0" rtlCol="0" anchor="ctr"/>
           <a:lstStyle/>
           <a:p>
-            <a:pPr algn="ctr" indent="0" marL="0">
+            <a:pPr marL="0" indent="0" algn="ctr">
               <a:buNone/>
             </a:pPr>
             <a:r>
@@ -2328,6 +2123,7 @@
         <a:solidFill>
           <a:srgbClr val="FFFFFF"/>
         </a:solidFill>
+        <a:effectLst/>
       </p:bgPr>
     </p:bg>
     <p:spTree>
@@ -2368,6 +2164,13 @@
             <a:prstDash val="solid"/>
           </a:ln>
         </p:spPr>
+        <p:txBody>
+          <a:bodyPr/>
+          <a:lstStyle/>
+          <a:p>
+            <a:endParaRPr lang="en-US"/>
+          </a:p>
+        </p:txBody>
       </p:sp>
       <p:sp>
         <p:nvSpPr>
@@ -2390,7 +2193,7 @@
           <a:bodyPr wrap="square" lIns="0" tIns="0" rIns="0" bIns="0" rtlCol="0" anchor="ctr"/>
           <a:lstStyle/>
           <a:p>
-            <a:pPr indent="0" marL="0">
+            <a:pPr marL="0" indent="0">
               <a:buNone/>
             </a:pPr>
             <a:r>
@@ -2429,7 +2232,7 @@
           <a:bodyPr wrap="square" lIns="0" tIns="0" rIns="0" bIns="0" rtlCol="0" anchor="ctr"/>
           <a:lstStyle/>
           <a:p>
-            <a:pPr algn="r" indent="0" marL="0">
+            <a:pPr marL="0" indent="0" algn="r">
               <a:buNone/>
             </a:pPr>
             <a:r>
@@ -2465,7 +2268,7 @@
           <a:bodyPr wrap="square" lIns="0" tIns="0" rIns="0" bIns="0" rtlCol="0" anchor="ctr"/>
           <a:lstStyle/>
           <a:p>
-            <a:pPr algn="r" indent="0" marL="0">
+            <a:pPr marL="0" indent="0" algn="r">
               <a:buNone/>
             </a:pPr>
             <a:r>
@@ -2501,7 +2304,7 @@
           <a:bodyPr wrap="square" lIns="0" tIns="0" rIns="0" bIns="0" rtlCol="0" anchor="ctr"/>
           <a:lstStyle/>
           <a:p>
-            <a:pPr indent="0" marL="0">
+            <a:pPr marL="0" indent="0">
               <a:buNone/>
             </a:pPr>
             <a:r>
@@ -2542,6 +2345,13 @@
             <a:prstDash val="solid"/>
           </a:ln>
         </p:spPr>
+        <p:txBody>
+          <a:bodyPr/>
+          <a:lstStyle/>
+          <a:p>
+            <a:endParaRPr lang="en-US"/>
+          </a:p>
+        </p:txBody>
       </p:sp>
       <p:sp>
         <p:nvSpPr>
@@ -2564,7 +2374,7 @@
           <a:bodyPr wrap="square" lIns="0" tIns="0" rIns="0" bIns="0" rtlCol="0" anchor="ctr"/>
           <a:lstStyle/>
           <a:p>
-            <a:pPr indent="0" marL="0">
+            <a:pPr marL="0" indent="0">
               <a:buNone/>
             </a:pPr>
             <a:r>
@@ -2598,11 +2408,11 @@
         </p:spPr>
         <p:txBody>
           <a:bodyPr wrap="square" lIns="0" tIns="0" rIns="0" bIns="0" rtlCol="0" anchor="ctr">
-            <a:normAutofit/>
+            <a:normAutofit lnSpcReduction="10000"/>
           </a:bodyPr>
           <a:lstStyle/>
           <a:p>
-            <a:pPr indent="0" marL="0">
+            <a:pPr marL="0" indent="0">
               <a:buNone/>
             </a:pPr>
             <a:r>
@@ -2616,7 +2426,7 @@
             <a:endParaRPr lang="en-US" sz="1250" dirty="0"/>
           </a:p>
           <a:p>
-            <a:pPr indent="0" marL="0">
+            <a:pPr marL="0" indent="0">
               <a:buNone/>
             </a:pPr>
             <a:r>
@@ -2630,7 +2440,7 @@
             <a:endParaRPr lang="en-US" sz="1250" dirty="0"/>
           </a:p>
           <a:p>
-            <a:pPr indent="0" marL="0">
+            <a:pPr marL="0" indent="0">
               <a:buNone/>
             </a:pPr>
             <a:r>
@@ -2671,6 +2481,13 @@
             <a:prstDash val="solid"/>
           </a:ln>
         </p:spPr>
+        <p:txBody>
+          <a:bodyPr/>
+          <a:lstStyle/>
+          <a:p>
+            <a:endParaRPr lang="en-US"/>
+          </a:p>
+        </p:txBody>
       </p:sp>
       <p:sp>
         <p:nvSpPr>
@@ -2693,7 +2510,7 @@
           <a:bodyPr wrap="square" lIns="0" tIns="0" rIns="0" bIns="0" rtlCol="0" anchor="ctr"/>
           <a:lstStyle/>
           <a:p>
-            <a:pPr indent="0" marL="0">
+            <a:pPr marL="0" indent="0">
               <a:buNone/>
             </a:pPr>
             <a:r>
@@ -2727,11 +2544,11 @@
         </p:spPr>
         <p:txBody>
           <a:bodyPr wrap="square" lIns="0" tIns="0" rIns="0" bIns="0" rtlCol="0" anchor="ctr">
-            <a:normAutofit/>
+            <a:normAutofit lnSpcReduction="10000"/>
           </a:bodyPr>
           <a:lstStyle/>
           <a:p>
-            <a:pPr indent="0" marL="0">
+            <a:pPr marL="0" indent="0">
               <a:buNone/>
             </a:pPr>
             <a:r>
@@ -2745,7 +2562,7 @@
             <a:endParaRPr lang="en-US" sz="1250" dirty="0"/>
           </a:p>
           <a:p>
-            <a:pPr indent="0" marL="0">
+            <a:pPr marL="0" indent="0">
               <a:buNone/>
             </a:pPr>
             <a:r>
@@ -2759,7 +2576,7 @@
             <a:endParaRPr lang="en-US" sz="1250" dirty="0"/>
           </a:p>
           <a:p>
-            <a:pPr indent="0" marL="0">
+            <a:pPr marL="0" indent="0">
               <a:buNone/>
             </a:pPr>
             <a:r>
@@ -2800,6 +2617,13 @@
             <a:prstDash val="solid"/>
           </a:ln>
         </p:spPr>
+        <p:txBody>
+          <a:bodyPr/>
+          <a:lstStyle/>
+          <a:p>
+            <a:endParaRPr lang="en-US"/>
+          </a:p>
+        </p:txBody>
       </p:sp>
       <p:sp>
         <p:nvSpPr>
@@ -2822,7 +2646,7 @@
           <a:bodyPr wrap="square" lIns="0" tIns="0" rIns="0" bIns="0" rtlCol="0" anchor="ctr"/>
           <a:lstStyle/>
           <a:p>
-            <a:pPr indent="0" marL="0">
+            <a:pPr marL="0" indent="0">
               <a:buNone/>
             </a:pPr>
             <a:r>
@@ -2856,11 +2680,11 @@
         </p:spPr>
         <p:txBody>
           <a:bodyPr wrap="square" lIns="0" tIns="0" rIns="0" bIns="0" rtlCol="0" anchor="ctr">
-            <a:normAutofit/>
+            <a:normAutofit lnSpcReduction="10000"/>
           </a:bodyPr>
           <a:lstStyle/>
           <a:p>
-            <a:pPr indent="0" marL="0">
+            <a:pPr marL="0" indent="0">
               <a:buNone/>
             </a:pPr>
             <a:r>
@@ -2874,7 +2698,7 @@
             <a:endParaRPr lang="en-US" sz="1250" dirty="0"/>
           </a:p>
           <a:p>
-            <a:pPr indent="0" marL="0">
+            <a:pPr marL="0" indent="0">
               <a:buNone/>
             </a:pPr>
             <a:r>
@@ -2888,7 +2712,7 @@
             <a:endParaRPr lang="en-US" sz="1250" dirty="0"/>
           </a:p>
           <a:p>
-            <a:pPr indent="0" marL="0">
+            <a:pPr marL="0" indent="0">
               <a:buNone/>
             </a:pPr>
             <a:r>
@@ -2929,6 +2753,13 @@
             <a:prstDash val="solid"/>
           </a:ln>
         </p:spPr>
+        <p:txBody>
+          <a:bodyPr/>
+          <a:lstStyle/>
+          <a:p>
+            <a:endParaRPr lang="en-US"/>
+          </a:p>
+        </p:txBody>
       </p:sp>
       <p:sp>
         <p:nvSpPr>
@@ -2951,7 +2782,7 @@
           <a:bodyPr wrap="square" lIns="0" tIns="0" rIns="0" bIns="0" rtlCol="0" anchor="ctr"/>
           <a:lstStyle/>
           <a:p>
-            <a:pPr indent="0" marL="0">
+            <a:pPr marL="0" indent="0">
               <a:buNone/>
             </a:pPr>
             <a:r>
@@ -2985,11 +2816,11 @@
         </p:spPr>
         <p:txBody>
           <a:bodyPr wrap="square" lIns="0" tIns="0" rIns="0" bIns="0" rtlCol="0" anchor="ctr">
-            <a:normAutofit/>
+            <a:normAutofit lnSpcReduction="10000"/>
           </a:bodyPr>
           <a:lstStyle/>
           <a:p>
-            <a:pPr indent="0" marL="0">
+            <a:pPr marL="0" indent="0">
               <a:buNone/>
             </a:pPr>
             <a:r>
@@ -3003,7 +2834,7 @@
             <a:endParaRPr lang="en-US" sz="1250" dirty="0"/>
           </a:p>
           <a:p>
-            <a:pPr indent="0" marL="0">
+            <a:pPr marL="0" indent="0">
               <a:buNone/>
             </a:pPr>
             <a:r>
@@ -3017,7 +2848,7 @@
             <a:endParaRPr lang="en-US" sz="1250" dirty="0"/>
           </a:p>
           <a:p>
-            <a:pPr indent="0" marL="0">
+            <a:pPr marL="0" indent="0">
               <a:buNone/>
             </a:pPr>
             <a:r>
@@ -3058,6 +2889,13 @@
             <a:prstDash val="solid"/>
           </a:ln>
         </p:spPr>
+        <p:txBody>
+          <a:bodyPr/>
+          <a:lstStyle/>
+          <a:p>
+            <a:endParaRPr lang="en-US"/>
+          </a:p>
+        </p:txBody>
       </p:sp>
       <p:sp>
         <p:nvSpPr>
@@ -3080,7 +2918,7 @@
           <a:bodyPr wrap="square" lIns="0" tIns="0" rIns="0" bIns="0" rtlCol="0" anchor="ctr"/>
           <a:lstStyle/>
           <a:p>
-            <a:pPr algn="ctr" indent="0" marL="0">
+            <a:pPr marL="0" indent="0" algn="ctr">
               <a:buNone/>
             </a:pPr>
             <a:r>
@@ -3094,7 +2932,7 @@
             <a:endParaRPr lang="en-US" sz="1250" dirty="0"/>
           </a:p>
           <a:p>
-            <a:pPr algn="ctr" indent="0" marL="0">
+            <a:pPr marL="0" indent="0" algn="ctr">
               <a:buNone/>
             </a:pPr>
             <a:r>
@@ -3108,7 +2946,7 @@
             <a:endParaRPr lang="en-US" sz="1250" dirty="0"/>
           </a:p>
           <a:p>
-            <a:pPr algn="ctr" indent="0" marL="0">
+            <a:pPr marL="0" indent="0" algn="ctr">
               <a:buNone/>
             </a:pPr>
             <a:r>
@@ -3122,7 +2960,7 @@
             <a:endParaRPr lang="en-US" sz="1250" dirty="0"/>
           </a:p>
           <a:p>
-            <a:pPr algn="ctr" indent="0" marL="0">
+            <a:pPr marL="0" indent="0" algn="ctr">
               <a:buNone/>
             </a:pPr>
             <a:r>
@@ -3153,6 +2991,7 @@
         <a:solidFill>
           <a:srgbClr val="FFFFFF"/>
         </a:solidFill>
+        <a:effectLst/>
       </p:bgPr>
     </p:bg>
     <p:spTree>
@@ -3193,6 +3032,13 @@
             <a:prstDash val="solid"/>
           </a:ln>
         </p:spPr>
+        <p:txBody>
+          <a:bodyPr/>
+          <a:lstStyle/>
+          <a:p>
+            <a:endParaRPr lang="en-US"/>
+          </a:p>
+        </p:txBody>
       </p:sp>
       <p:sp>
         <p:nvSpPr>
@@ -3215,7 +3061,7 @@
           <a:bodyPr wrap="square" lIns="0" tIns="0" rIns="0" bIns="0" rtlCol="0" anchor="ctr"/>
           <a:lstStyle/>
           <a:p>
-            <a:pPr indent="0" marL="0">
+            <a:pPr marL="0" indent="0">
               <a:buNone/>
             </a:pPr>
             <a:r>
@@ -3254,7 +3100,7 @@
           <a:bodyPr wrap="square" lIns="0" tIns="0" rIns="0" bIns="0" rtlCol="0" anchor="ctr"/>
           <a:lstStyle/>
           <a:p>
-            <a:pPr algn="r" indent="0" marL="0">
+            <a:pPr marL="0" indent="0" algn="r">
               <a:buNone/>
             </a:pPr>
             <a:r>
@@ -3290,7 +3136,7 @@
           <a:bodyPr wrap="square" lIns="0" tIns="0" rIns="0" bIns="0" rtlCol="0" anchor="ctr"/>
           <a:lstStyle/>
           <a:p>
-            <a:pPr algn="r" indent="0" marL="0">
+            <a:pPr marL="0" indent="0" algn="r">
               <a:buNone/>
             </a:pPr>
             <a:r>
@@ -3307,25 +3153,37 @@
       </p:sp>
       <p:pic>
         <p:nvPicPr>
-          <p:cNvPr id="6" name="Image 0" descr="/mnt/data/report_extract/word/media/image3.png">    </p:cNvPr>
+          <p:cNvPr id="6" name="Image 0" descr="/mnt/data/report_extract/word/media/image3.png"/>
           <p:cNvPicPr>
             <a:picLocks noChangeAspect="1"/>
           </p:cNvPicPr>
           <p:nvPr/>
         </p:nvPicPr>
         <p:blipFill>
-          <a:blip r:embed="rId1"/>
-          <a:srcRect l="0" r="0" t="11513" b="11513"/>
+          <a:blip r:embed="rId3"/>
+          <a:srcRect t="11513" b="11513"/>
           <a:stretch/>
         </p:blipFill>
         <p:spPr>
           <a:xfrm>
             <a:off x="502920" y="987552"/>
-            <a:ext cx="11201400" cy="3218688"/>
-          </a:xfrm>
-          <a:prstGeom prst="rect">
-            <a:avLst/>
-          </a:prstGeom>
+            <a:ext cx="11201400" cy="3571240"/>
+          </a:xfrm>
+          <a:prstGeom prst="rect">
+            <a:avLst/>
+          </a:prstGeom>
+          <a:ln w="19050">
+            <a:solidFill>
+              <a:schemeClr val="tx1"/>
+            </a:solidFill>
+          </a:ln>
+          <a:effectLst>
+            <a:outerShdw blurRad="292100" dist="139700" dir="2700000" algn="tl" rotWithShape="0">
+              <a:srgbClr val="333333">
+                <a:alpha val="65000"/>
+              </a:srgbClr>
+            </a:outerShdw>
+          </a:effectLst>
         </p:spPr>
       </p:pic>
       <p:sp>
@@ -3336,7 +3194,7 @@
         </p:nvSpPr>
         <p:spPr>
           <a:xfrm>
-            <a:off x="685800" y="4553712"/>
+            <a:off x="685800" y="4878832"/>
             <a:ext cx="6035040" cy="475488"/>
           </a:xfrm>
           <a:prstGeom prst="rect">
@@ -3351,7 +3209,7 @@
           </a:bodyPr>
           <a:lstStyle/>
           <a:p>
-            <a:pPr indent="0" marL="0">
+            <a:pPr marL="0" indent="0">
               <a:buNone/>
             </a:pPr>
             <a:r>
@@ -3366,30 +3224,6 @@
           </a:p>
         </p:txBody>
       </p:sp>
-      <p:pic>
-        <p:nvPicPr>
-          <p:cNvPr id="8" name="Image 1" descr="/mnt/data/report_extract/word/media/image4.png">    </p:cNvPr>
-          <p:cNvPicPr>
-            <a:picLocks noChangeAspect="1"/>
-          </p:cNvPicPr>
-          <p:nvPr/>
-        </p:nvPicPr>
-        <p:blipFill>
-          <a:blip r:embed="rId2"/>
-          <a:stretch>
-            <a:fillRect/>
-          </a:stretch>
-        </p:blipFill>
-        <p:spPr>
-          <a:xfrm>
-            <a:off x="8542284" y="4462272"/>
-            <a:ext cx="1477752" cy="1170432"/>
-          </a:xfrm>
-          <a:prstGeom prst="rect">
-            <a:avLst/>
-          </a:prstGeom>
-        </p:spPr>
-      </p:pic>
       <p:sp>
         <p:nvSpPr>
           <p:cNvPr id="9" name="Shape 5"/>
@@ -3398,7 +3232,7 @@
         </p:nvSpPr>
         <p:spPr>
           <a:xfrm>
-            <a:off x="914400" y="5349240"/>
+            <a:off x="914400" y="5674360"/>
             <a:ext cx="3246120" cy="457200"/>
           </a:xfrm>
           <a:prstGeom prst="roundRect">
@@ -3416,6 +3250,13 @@
             <a:prstDash val="solid"/>
           </a:ln>
         </p:spPr>
+        <p:txBody>
+          <a:bodyPr/>
+          <a:lstStyle/>
+          <a:p>
+            <a:endParaRPr lang="en-US"/>
+          </a:p>
+        </p:txBody>
       </p:sp>
       <p:sp>
         <p:nvSpPr>
@@ -3425,7 +3266,7 @@
         </p:nvSpPr>
         <p:spPr>
           <a:xfrm>
-            <a:off x="1024128" y="5458968"/>
+            <a:off x="1024128" y="5784088"/>
             <a:ext cx="3026664" cy="237744"/>
           </a:xfrm>
           <a:prstGeom prst="rect">
@@ -3438,7 +3279,7 @@
           <a:bodyPr wrap="square" lIns="0" tIns="0" rIns="0" bIns="0" rtlCol="0" anchor="ctr"/>
           <a:lstStyle/>
           <a:p>
-            <a:pPr algn="ctr" indent="0" marL="0">
+            <a:pPr marL="0" indent="0" algn="ctr">
               <a:buNone/>
             </a:pPr>
             <a:r>
@@ -3461,7 +3302,7 @@
         </p:nvSpPr>
         <p:spPr>
           <a:xfrm>
-            <a:off x="4389120" y="5349240"/>
+            <a:off x="4389120" y="5674360"/>
             <a:ext cx="2697480" cy="457200"/>
           </a:xfrm>
           <a:prstGeom prst="roundRect">
@@ -3479,6 +3320,13 @@
             <a:prstDash val="solid"/>
           </a:ln>
         </p:spPr>
+        <p:txBody>
+          <a:bodyPr/>
+          <a:lstStyle/>
+          <a:p>
+            <a:endParaRPr lang="en-US"/>
+          </a:p>
+        </p:txBody>
       </p:sp>
       <p:sp>
         <p:nvSpPr>
@@ -3488,7 +3336,7 @@
         </p:nvSpPr>
         <p:spPr>
           <a:xfrm>
-            <a:off x="4498848" y="5458968"/>
+            <a:off x="4498848" y="5784088"/>
             <a:ext cx="2478024" cy="237744"/>
           </a:xfrm>
           <a:prstGeom prst="rect">
@@ -3501,7 +3349,7 @@
           <a:bodyPr wrap="square" lIns="0" tIns="0" rIns="0" bIns="0" rtlCol="0" anchor="ctr"/>
           <a:lstStyle/>
           <a:p>
-            <a:pPr algn="ctr" indent="0" marL="0">
+            <a:pPr marL="0" indent="0" algn="ctr">
               <a:buNone/>
             </a:pPr>
             <a:r>
@@ -3532,6 +3380,7 @@
         <a:solidFill>
           <a:srgbClr val="FFFFFF"/>
         </a:solidFill>
+        <a:effectLst/>
       </p:bgPr>
     </p:bg>
     <p:spTree>
@@ -3572,6 +3421,13 @@
             <a:prstDash val="solid"/>
           </a:ln>
         </p:spPr>
+        <p:txBody>
+          <a:bodyPr/>
+          <a:lstStyle/>
+          <a:p>
+            <a:endParaRPr lang="en-US"/>
+          </a:p>
+        </p:txBody>
       </p:sp>
       <p:sp>
         <p:nvSpPr>
@@ -3594,7 +3450,7 @@
           <a:bodyPr wrap="square" lIns="0" tIns="0" rIns="0" bIns="0" rtlCol="0" anchor="ctr"/>
           <a:lstStyle/>
           <a:p>
-            <a:pPr indent="0" marL="0">
+            <a:pPr marL="0" indent="0">
               <a:buNone/>
             </a:pPr>
             <a:r>
@@ -3633,7 +3489,7 @@
           <a:bodyPr wrap="square" lIns="0" tIns="0" rIns="0" bIns="0" rtlCol="0" anchor="ctr"/>
           <a:lstStyle/>
           <a:p>
-            <a:pPr algn="r" indent="0" marL="0">
+            <a:pPr marL="0" indent="0" algn="r">
               <a:buNone/>
             </a:pPr>
             <a:r>
@@ -3669,7 +3525,7 @@
           <a:bodyPr wrap="square" lIns="0" tIns="0" rIns="0" bIns="0" rtlCol="0" anchor="ctr"/>
           <a:lstStyle/>
           <a:p>
-            <a:pPr algn="r" indent="0" marL="0">
+            <a:pPr marL="0" indent="0" algn="r">
               <a:buNone/>
             </a:pPr>
             <a:r>
@@ -3705,7 +3561,7 @@
           <a:bodyPr wrap="square" lIns="0" tIns="0" rIns="0" bIns="0" rtlCol="0" anchor="ctr"/>
           <a:lstStyle/>
           <a:p>
-            <a:pPr indent="0" marL="0">
+            <a:pPr marL="0" indent="0">
               <a:buNone/>
             </a:pPr>
             <a:r>
@@ -3796,7 +3652,7 @@
         </p:nvSpPr>
         <p:spPr>
           <a:xfrm>
-            <a:off x="7498080" y="1188720"/>
+            <a:off x="822960" y="3376168"/>
             <a:ext cx="3291840" cy="3108960"/>
           </a:xfrm>
           <a:prstGeom prst="roundRect">
@@ -3814,6 +3670,13 @@
             <a:prstDash val="solid"/>
           </a:ln>
         </p:spPr>
+        <p:txBody>
+          <a:bodyPr/>
+          <a:lstStyle/>
+          <a:p>
+            <a:endParaRPr lang="en-US"/>
+          </a:p>
+        </p:txBody>
       </p:sp>
       <p:sp>
         <p:nvSpPr>
@@ -3823,7 +3686,7 @@
         </p:nvSpPr>
         <p:spPr>
           <a:xfrm>
-            <a:off x="7726680" y="1554480"/>
+            <a:off x="1051560" y="3741928"/>
             <a:ext cx="2834640" cy="274320"/>
           </a:xfrm>
           <a:prstGeom prst="rect">
@@ -3836,7 +3699,7 @@
           <a:bodyPr wrap="square" lIns="0" tIns="0" rIns="0" bIns="0" rtlCol="0" anchor="ctr"/>
           <a:lstStyle/>
           <a:p>
-            <a:pPr algn="ctr" indent="0" marL="0">
+            <a:pPr marL="0" indent="0" algn="ctr">
               <a:buNone/>
             </a:pPr>
             <a:r>
@@ -3859,7 +3722,7 @@
         </p:nvSpPr>
         <p:spPr>
           <a:xfrm>
-            <a:off x="7818120" y="2148840"/>
+            <a:off x="1143000" y="4336288"/>
             <a:ext cx="2651760" cy="1234440"/>
           </a:xfrm>
           <a:prstGeom prst="rect">
@@ -3874,7 +3737,7 @@
           </a:bodyPr>
           <a:lstStyle/>
           <a:p>
-            <a:pPr algn="ctr" indent="0" marL="0">
+            <a:pPr marL="0" indent="0" algn="ctr">
               <a:buNone/>
             </a:pPr>
             <a:r>
@@ -3888,7 +3751,7 @@
             <a:endParaRPr lang="en-US" sz="2000" dirty="0"/>
           </a:p>
           <a:p>
-            <a:pPr algn="ctr" indent="0" marL="0">
+            <a:pPr marL="0" indent="0" algn="ctr">
               <a:buNone/>
             </a:pPr>
             <a:r>
@@ -3902,7 +3765,7 @@
             <a:endParaRPr lang="en-US" sz="2000" dirty="0"/>
           </a:p>
           <a:p>
-            <a:pPr algn="ctr" indent="0" marL="0">
+            <a:pPr marL="0" indent="0" algn="ctr">
               <a:buNone/>
             </a:pPr>
             <a:r>
@@ -3925,7 +3788,7 @@
         </p:nvSpPr>
         <p:spPr>
           <a:xfrm>
-            <a:off x="8001000" y="3703320"/>
+            <a:off x="1325880" y="5890768"/>
             <a:ext cx="2286000" cy="0"/>
           </a:xfrm>
           <a:prstGeom prst="line">
@@ -3939,6 +3802,13 @@
             <a:prstDash val="solid"/>
           </a:ln>
         </p:spPr>
+        <p:txBody>
+          <a:bodyPr/>
+          <a:lstStyle/>
+          <a:p>
+            <a:endParaRPr lang="en-US"/>
+          </a:p>
+        </p:txBody>
       </p:sp>
       <p:sp>
         <p:nvSpPr>
@@ -3948,20 +3818,20 @@
         </p:nvSpPr>
         <p:spPr>
           <a:xfrm>
-            <a:off x="822960" y="5074920"/>
-            <a:ext cx="10515600" cy="457200"/>
-          </a:xfrm>
-          <a:prstGeom prst="rect">
-            <a:avLst/>
-          </a:prstGeom>
-          <a:noFill/>
-          <a:ln/>
-        </p:spPr>
-        <p:txBody>
-          <a:bodyPr wrap="square" lIns="0" tIns="0" rIns="0" bIns="0" rtlCol="0" anchor="ctr"/>
-          <a:lstStyle/>
-          <a:p>
-            <a:pPr algn="ctr" indent="0" marL="0">
+            <a:off x="3794760" y="5797296"/>
+            <a:ext cx="7711135" cy="457200"/>
+          </a:xfrm>
+          <a:prstGeom prst="rect">
+            <a:avLst/>
+          </a:prstGeom>
+          <a:noFill/>
+          <a:ln/>
+        </p:spPr>
+        <p:txBody>
+          <a:bodyPr wrap="square" lIns="0" tIns="0" rIns="0" bIns="0" rtlCol="0" anchor="ctr"/>
+          <a:lstStyle/>
+          <a:p>
+            <a:pPr marL="0" indent="0" algn="ctr">
               <a:buNone/>
             </a:pPr>
             <a:r>
@@ -3976,6 +3846,54 @@
           </a:p>
         </p:txBody>
       </p:sp>
+      <p:pic>
+        <p:nvPicPr>
+          <p:cNvPr id="13" name="Picture 12">
+            <a:extLst>
+              <a:ext uri="{FF2B5EF4-FFF2-40B4-BE49-F238E27FC236}">
+                <a16:creationId xmlns:a16="http://schemas.microsoft.com/office/drawing/2014/main" id="{82A2C31A-7D61-20A8-9B6E-E45881156BB3}"/>
+              </a:ext>
+            </a:extLst>
+          </p:cNvPr>
+          <p:cNvPicPr>
+            <a:picLocks noChangeAspect="1"/>
+          </p:cNvPicPr>
+          <p:nvPr/>
+        </p:nvPicPr>
+        <p:blipFill rotWithShape="1">
+          <a:blip r:embed="rId3"/>
+          <a:srcRect r="17261"/>
+          <a:stretch>
+            <a:fillRect/>
+          </a:stretch>
+        </p:blipFill>
+        <p:spPr bwMode="auto">
+          <a:xfrm>
+            <a:off x="6660515" y="1280160"/>
+            <a:ext cx="5089525" cy="3792220"/>
+          </a:xfrm>
+          <a:prstGeom prst="rect">
+            <a:avLst/>
+          </a:prstGeom>
+          <a:ln w="19050">
+            <a:solidFill>
+              <a:schemeClr val="tx1"/>
+            </a:solidFill>
+          </a:ln>
+          <a:effectLst>
+            <a:outerShdw blurRad="292100" dist="139700" dir="2700000" algn="tl" rotWithShape="0">
+              <a:srgbClr val="333333">
+                <a:alpha val="65000"/>
+              </a:srgbClr>
+            </a:outerShdw>
+          </a:effectLst>
+          <a:extLst>
+            <a:ext uri="{53640926-AAD7-44D8-BBD7-CCE9431645EC}">
+              <a14:shadowObscured xmlns:a14="http://schemas.microsoft.com/office/drawing/2010/main"/>
+            </a:ext>
+          </a:extLst>
+        </p:spPr>
+      </p:pic>
     </p:spTree>
   </p:cSld>
   <p:clrMapOvr>
@@ -3992,6 +3910,7 @@
         <a:solidFill>
           <a:srgbClr val="FFFFFF"/>
         </a:solidFill>
+        <a:effectLst/>
       </p:bgPr>
     </p:bg>
     <p:spTree>
@@ -4032,6 +3951,13 @@
             <a:prstDash val="solid"/>
           </a:ln>
         </p:spPr>
+        <p:txBody>
+          <a:bodyPr/>
+          <a:lstStyle/>
+          <a:p>
+            <a:endParaRPr lang="en-US"/>
+          </a:p>
+        </p:txBody>
       </p:sp>
       <p:sp>
         <p:nvSpPr>
@@ -4054,7 +3980,7 @@
           <a:bodyPr wrap="square" lIns="0" tIns="0" rIns="0" bIns="0" rtlCol="0" anchor="ctr"/>
           <a:lstStyle/>
           <a:p>
-            <a:pPr indent="0" marL="0">
+            <a:pPr marL="0" indent="0">
               <a:buNone/>
             </a:pPr>
             <a:r>
@@ -4093,7 +4019,7 @@
           <a:bodyPr wrap="square" lIns="0" tIns="0" rIns="0" bIns="0" rtlCol="0" anchor="ctr"/>
           <a:lstStyle/>
           <a:p>
-            <a:pPr algn="r" indent="0" marL="0">
+            <a:pPr marL="0" indent="0" algn="r">
               <a:buNone/>
             </a:pPr>
             <a:r>
@@ -4129,7 +4055,7 @@
           <a:bodyPr wrap="square" lIns="0" tIns="0" rIns="0" bIns="0" rtlCol="0" anchor="ctr"/>
           <a:lstStyle/>
           <a:p>
-            <a:pPr algn="r" indent="0" marL="0">
+            <a:pPr marL="0" indent="0" algn="r">
               <a:buNone/>
             </a:pPr>
             <a:r>
@@ -4165,7 +4091,7 @@
           <a:bodyPr wrap="square" lIns="0" tIns="0" rIns="0" bIns="0" rtlCol="0" anchor="ctr"/>
           <a:lstStyle/>
           <a:p>
-            <a:pPr indent="0" marL="0">
+            <a:pPr marL="0" indent="0">
               <a:buNone/>
             </a:pPr>
             <a:r>
@@ -4199,11 +4125,11 @@
         </p:spPr>
         <p:txBody>
           <a:bodyPr wrap="square" lIns="254" tIns="254" rIns="254" bIns="254" rtlCol="0" anchor="ctr">
-            <a:normAutofit/>
+            <a:normAutofit fontScale="85000" lnSpcReduction="10000"/>
           </a:bodyPr>
           <a:lstStyle/>
           <a:p>
-            <a:pPr indent="0" marL="0">
+            <a:pPr marL="0" indent="0">
               <a:buNone/>
             </a:pPr>
             <a:r>
@@ -4240,6 +4166,13 @@
             <a:prstDash val="solid"/>
           </a:ln>
         </p:spPr>
+        <p:txBody>
+          <a:bodyPr/>
+          <a:lstStyle/>
+          <a:p>
+            <a:endParaRPr lang="en-US"/>
+          </a:p>
+        </p:txBody>
       </p:sp>
       <p:sp>
         <p:nvSpPr>
@@ -4319,7 +4252,7 @@
           <a:bodyPr wrap="square" lIns="0" tIns="0" rIns="0" bIns="0" rtlCol="0" anchor="ctr"/>
           <a:lstStyle/>
           <a:p>
-            <a:pPr indent="0" marL="0">
+            <a:pPr marL="0" indent="0">
               <a:buNone/>
             </a:pPr>
             <a:r>
@@ -4360,6 +4293,13 @@
             <a:prstDash val="solid"/>
           </a:ln>
         </p:spPr>
+        <p:txBody>
+          <a:bodyPr/>
+          <a:lstStyle/>
+          <a:p>
+            <a:endParaRPr lang="en-US"/>
+          </a:p>
+        </p:txBody>
       </p:sp>
       <p:sp>
         <p:nvSpPr>
@@ -4382,7 +4322,7 @@
           <a:bodyPr wrap="square" lIns="0" tIns="0" rIns="0" bIns="0" rtlCol="0" anchor="ctr"/>
           <a:lstStyle/>
           <a:p>
-            <a:pPr indent="0" marL="0">
+            <a:pPr marL="0" indent="0">
               <a:buNone/>
             </a:pPr>
             <a:r>
@@ -4418,7 +4358,7 @@
           <a:bodyPr wrap="square" lIns="0" tIns="0" rIns="0" bIns="0" rtlCol="0" anchor="ctr"/>
           <a:lstStyle/>
           <a:p>
-            <a:pPr indent="0" marL="0">
+            <a:pPr marL="0" indent="0">
               <a:buNone/>
             </a:pPr>
             <a:r>
@@ -4459,6 +4399,13 @@
             <a:prstDash val="solid"/>
           </a:ln>
         </p:spPr>
+        <p:txBody>
+          <a:bodyPr/>
+          <a:lstStyle/>
+          <a:p>
+            <a:endParaRPr lang="en-US"/>
+          </a:p>
+        </p:txBody>
       </p:sp>
       <p:sp>
         <p:nvSpPr>
@@ -4481,7 +4428,7 @@
           <a:bodyPr wrap="square" lIns="0" tIns="0" rIns="0" bIns="0" rtlCol="0" anchor="ctr"/>
           <a:lstStyle/>
           <a:p>
-            <a:pPr indent="0" marL="0">
+            <a:pPr marL="0" indent="0">
               <a:buNone/>
             </a:pPr>
             <a:r>
@@ -4517,7 +4464,7 @@
           <a:bodyPr wrap="square" lIns="0" tIns="0" rIns="0" bIns="0" rtlCol="0" anchor="ctr"/>
           <a:lstStyle/>
           <a:p>
-            <a:pPr indent="0" marL="0">
+            <a:pPr marL="0" indent="0">
               <a:buNone/>
             </a:pPr>
             <a:r>
@@ -4558,6 +4505,13 @@
             <a:prstDash val="solid"/>
           </a:ln>
         </p:spPr>
+        <p:txBody>
+          <a:bodyPr/>
+          <a:lstStyle/>
+          <a:p>
+            <a:endParaRPr lang="en-US"/>
+          </a:p>
+        </p:txBody>
       </p:sp>
       <p:sp>
         <p:nvSpPr>
@@ -4580,7 +4534,7 @@
           <a:bodyPr wrap="square" lIns="0" tIns="0" rIns="0" bIns="0" rtlCol="0" anchor="ctr"/>
           <a:lstStyle/>
           <a:p>
-            <a:pPr indent="0" marL="0">
+            <a:pPr marL="0" indent="0">
               <a:buNone/>
             </a:pPr>
             <a:r>
@@ -4616,7 +4570,7 @@
           <a:bodyPr wrap="square" lIns="0" tIns="0" rIns="0" bIns="0" rtlCol="0" anchor="ctr"/>
           <a:lstStyle/>
           <a:p>
-            <a:pPr indent="0" marL="0">
+            <a:pPr marL="0" indent="0">
               <a:buNone/>
             </a:pPr>
             <a:r>
@@ -4657,6 +4611,13 @@
             <a:prstDash val="solid"/>
           </a:ln>
         </p:spPr>
+        <p:txBody>
+          <a:bodyPr/>
+          <a:lstStyle/>
+          <a:p>
+            <a:endParaRPr lang="en-US"/>
+          </a:p>
+        </p:txBody>
       </p:sp>
       <p:sp>
         <p:nvSpPr>
@@ -4679,7 +4640,7 @@
           <a:bodyPr wrap="square" lIns="0" tIns="0" rIns="0" bIns="0" rtlCol="0" anchor="ctr"/>
           <a:lstStyle/>
           <a:p>
-            <a:pPr indent="0" marL="0">
+            <a:pPr marL="0" indent="0">
               <a:buNone/>
             </a:pPr>
             <a:r>
@@ -4715,7 +4676,7 @@
           <a:bodyPr wrap="square" lIns="0" tIns="0" rIns="0" bIns="0" rtlCol="0" anchor="ctr"/>
           <a:lstStyle/>
           <a:p>
-            <a:pPr indent="0" marL="0">
+            <a:pPr marL="0" indent="0">
               <a:buNone/>
             </a:pPr>
             <a:r>
@@ -4756,6 +4717,13 @@
             <a:prstDash val="solid"/>
           </a:ln>
         </p:spPr>
+        <p:txBody>
+          <a:bodyPr/>
+          <a:lstStyle/>
+          <a:p>
+            <a:endParaRPr lang="en-US"/>
+          </a:p>
+        </p:txBody>
       </p:sp>
       <p:sp>
         <p:nvSpPr>
@@ -4778,7 +4746,7 @@
           <a:bodyPr wrap="square" lIns="0" tIns="0" rIns="0" bIns="0" rtlCol="0" anchor="ctr"/>
           <a:lstStyle/>
           <a:p>
-            <a:pPr indent="0" marL="0">
+            <a:pPr marL="0" indent="0">
               <a:buNone/>
             </a:pPr>
             <a:r>
@@ -4814,7 +4782,7 @@
           <a:bodyPr wrap="square" lIns="0" tIns="0" rIns="0" bIns="0" rtlCol="0" anchor="ctr"/>
           <a:lstStyle/>
           <a:p>
-            <a:pPr indent="0" marL="0">
+            <a:pPr marL="0" indent="0">
               <a:buNone/>
             </a:pPr>
             <a:r>
@@ -4855,6 +4823,13 @@
             <a:prstDash val="solid"/>
           </a:ln>
         </p:spPr>
+        <p:txBody>
+          <a:bodyPr/>
+          <a:lstStyle/>
+          <a:p>
+            <a:endParaRPr lang="en-US"/>
+          </a:p>
+        </p:txBody>
       </p:sp>
       <p:sp>
         <p:nvSpPr>
@@ -4877,7 +4852,7 @@
           <a:bodyPr wrap="square" lIns="0" tIns="0" rIns="0" bIns="0" rtlCol="0" anchor="ctr"/>
           <a:lstStyle/>
           <a:p>
-            <a:pPr indent="0" marL="0">
+            <a:pPr marL="0" indent="0">
               <a:buNone/>
             </a:pPr>
             <a:r>
@@ -4913,7 +4888,7 @@
           <a:bodyPr wrap="square" lIns="0" tIns="0" rIns="0" bIns="0" rtlCol="0" anchor="ctr"/>
           <a:lstStyle/>
           <a:p>
-            <a:pPr indent="0" marL="0">
+            <a:pPr marL="0" indent="0">
               <a:buNone/>
             </a:pPr>
             <a:r>
@@ -4954,6 +4929,13 @@
             <a:prstDash val="solid"/>
           </a:ln>
         </p:spPr>
+        <p:txBody>
+          <a:bodyPr/>
+          <a:lstStyle/>
+          <a:p>
+            <a:endParaRPr lang="en-US"/>
+          </a:p>
+        </p:txBody>
       </p:sp>
       <p:sp>
         <p:nvSpPr>
@@ -4976,7 +4958,7 @@
           <a:bodyPr wrap="square" lIns="0" tIns="0" rIns="0" bIns="0" rtlCol="0" anchor="ctr"/>
           <a:lstStyle/>
           <a:p>
-            <a:pPr indent="0" marL="0">
+            <a:pPr marL="0" indent="0">
               <a:buNone/>
             </a:pPr>
             <a:r>
@@ -5012,7 +4994,7 @@
           <a:bodyPr wrap="square" lIns="0" tIns="0" rIns="0" bIns="0" rtlCol="0" anchor="ctr"/>
           <a:lstStyle/>
           <a:p>
-            <a:pPr indent="0" marL="0">
+            <a:pPr marL="0" indent="0">
               <a:buNone/>
             </a:pPr>
             <a:r>
@@ -5043,6 +5025,7 @@
         <a:solidFill>
           <a:srgbClr val="FFFFFF"/>
         </a:solidFill>
+        <a:effectLst/>
       </p:bgPr>
     </p:bg>
     <p:spTree>
@@ -5083,6 +5066,13 @@
             <a:prstDash val="solid"/>
           </a:ln>
         </p:spPr>
+        <p:txBody>
+          <a:bodyPr/>
+          <a:lstStyle/>
+          <a:p>
+            <a:endParaRPr lang="en-US"/>
+          </a:p>
+        </p:txBody>
       </p:sp>
       <p:sp>
         <p:nvSpPr>
@@ -5105,7 +5095,7 @@
           <a:bodyPr wrap="square" lIns="0" tIns="0" rIns="0" bIns="0" rtlCol="0" anchor="ctr"/>
           <a:lstStyle/>
           <a:p>
-            <a:pPr indent="0" marL="0">
+            <a:pPr marL="0" indent="0">
               <a:buNone/>
             </a:pPr>
             <a:r>
@@ -5144,7 +5134,7 @@
           <a:bodyPr wrap="square" lIns="0" tIns="0" rIns="0" bIns="0" rtlCol="0" anchor="ctr"/>
           <a:lstStyle/>
           <a:p>
-            <a:pPr algn="r" indent="0" marL="0">
+            <a:pPr marL="0" indent="0" algn="r">
               <a:buNone/>
             </a:pPr>
             <a:r>
@@ -5180,7 +5170,7 @@
           <a:bodyPr wrap="square" lIns="0" tIns="0" rIns="0" bIns="0" rtlCol="0" anchor="ctr"/>
           <a:lstStyle/>
           <a:p>
-            <a:pPr algn="r" indent="0" marL="0">
+            <a:pPr marL="0" indent="0" algn="r">
               <a:buNone/>
             </a:pPr>
             <a:r>
@@ -5216,7 +5206,7 @@
           <a:bodyPr wrap="square" lIns="0" tIns="0" rIns="0" bIns="0" rtlCol="0" anchor="ctr"/>
           <a:lstStyle/>
           <a:p>
-            <a:pPr indent="0" marL="0">
+            <a:pPr marL="0" indent="0">
               <a:buNone/>
             </a:pPr>
             <a:r>
@@ -5255,6 +5245,13 @@
             <a:prstDash val="solid"/>
           </a:ln>
         </p:spPr>
+        <p:txBody>
+          <a:bodyPr/>
+          <a:lstStyle/>
+          <a:p>
+            <a:endParaRPr lang="en-US"/>
+          </a:p>
+        </p:txBody>
       </p:sp>
       <p:sp>
         <p:nvSpPr>
@@ -5280,6 +5277,13 @@
             <a:prstDash val="solid"/>
           </a:ln>
         </p:spPr>
+        <p:txBody>
+          <a:bodyPr/>
+          <a:lstStyle/>
+          <a:p>
+            <a:endParaRPr lang="en-US"/>
+          </a:p>
+        </p:txBody>
       </p:sp>
       <p:sp>
         <p:nvSpPr>
@@ -5302,7 +5306,7 @@
           <a:bodyPr wrap="square" lIns="0" tIns="0" rIns="0" bIns="0" rtlCol="0" anchor="ctr"/>
           <a:lstStyle/>
           <a:p>
-            <a:pPr algn="ctr" indent="0" marL="0">
+            <a:pPr marL="0" indent="0" algn="ctr">
               <a:buNone/>
             </a:pPr>
             <a:r>
@@ -5316,7 +5320,7 @@
             <a:endParaRPr lang="en-US" sz="1400" dirty="0"/>
           </a:p>
           <a:p>
-            <a:pPr algn="ctr" indent="0" marL="0">
+            <a:pPr marL="0" indent="0" algn="ctr">
               <a:buNone/>
             </a:pPr>
             <a:r>
@@ -5355,6 +5359,13 @@
             <a:prstDash val="solid"/>
           </a:ln>
         </p:spPr>
+        <p:txBody>
+          <a:bodyPr/>
+          <a:lstStyle/>
+          <a:p>
+            <a:endParaRPr lang="en-US"/>
+          </a:p>
+        </p:txBody>
       </p:sp>
       <p:sp>
         <p:nvSpPr>
@@ -5377,7 +5388,7 @@
           <a:bodyPr wrap="square" lIns="0" tIns="0" rIns="0" bIns="0" rtlCol="0" anchor="ctr"/>
           <a:lstStyle/>
           <a:p>
-            <a:pPr algn="ctr" indent="0" marL="0">
+            <a:pPr marL="0" indent="0" algn="ctr">
               <a:buNone/>
             </a:pPr>
             <a:r>
@@ -5391,7 +5402,7 @@
             <a:endParaRPr lang="en-US" sz="1250" dirty="0"/>
           </a:p>
           <a:p>
-            <a:pPr algn="ctr" indent="0" marL="0">
+            <a:pPr marL="0" indent="0" algn="ctr">
               <a:buNone/>
             </a:pPr>
             <a:r>
@@ -5427,7 +5438,7 @@
           <a:bodyPr wrap="square" lIns="0" tIns="0" rIns="0" bIns="0" rtlCol="0" anchor="ctr"/>
           <a:lstStyle/>
           <a:p>
-            <a:pPr indent="0" marL="0">
+            <a:pPr marL="0" indent="0">
               <a:buNone/>
             </a:pPr>
             <a:r>
@@ -5463,7 +5474,7 @@
           <a:bodyPr wrap="square" lIns="0" tIns="0" rIns="0" bIns="0" rtlCol="0" anchor="ctr"/>
           <a:lstStyle/>
           <a:p>
-            <a:pPr algn="ctr" indent="0" marL="0">
+            <a:pPr marL="0" indent="0" algn="ctr">
               <a:buNone/>
             </a:pPr>
             <a:r>
@@ -5499,7 +5510,7 @@
           <a:bodyPr wrap="square" lIns="0" tIns="0" rIns="0" bIns="0" rtlCol="0" anchor="ctr"/>
           <a:lstStyle/>
           <a:p>
-            <a:pPr indent="0" marL="0">
+            <a:pPr marL="0" indent="0">
               <a:buNone/>
             </a:pPr>
             <a:r>
@@ -5540,6 +5551,13 @@
             <a:prstDash val="solid"/>
           </a:ln>
         </p:spPr>
+        <p:txBody>
+          <a:bodyPr/>
+          <a:lstStyle/>
+          <a:p>
+            <a:endParaRPr lang="en-US"/>
+          </a:p>
+        </p:txBody>
       </p:sp>
       <p:sp>
         <p:nvSpPr>
@@ -5562,7 +5580,7 @@
           <a:bodyPr wrap="square" lIns="0" tIns="0" rIns="0" bIns="0" rtlCol="0" anchor="ctr"/>
           <a:lstStyle/>
           <a:p>
-            <a:pPr algn="ctr" indent="0" marL="0">
+            <a:pPr marL="0" indent="0" algn="ctr">
               <a:buNone/>
             </a:pPr>
             <a:r>
@@ -5576,7 +5594,7 @@
             <a:endParaRPr lang="en-US" sz="950" dirty="0"/>
           </a:p>
           <a:p>
-            <a:pPr algn="ctr" indent="0" marL="0">
+            <a:pPr marL="0" indent="0" algn="ctr">
               <a:buNone/>
             </a:pPr>
             <a:r>
@@ -5617,6 +5635,13 @@
             <a:prstDash val="solid"/>
           </a:ln>
         </p:spPr>
+        <p:txBody>
+          <a:bodyPr/>
+          <a:lstStyle/>
+          <a:p>
+            <a:endParaRPr lang="en-US"/>
+          </a:p>
+        </p:txBody>
       </p:sp>
       <p:sp>
         <p:nvSpPr>
@@ -5639,7 +5664,7 @@
           <a:bodyPr wrap="square" lIns="0" tIns="0" rIns="0" bIns="0" rtlCol="0" anchor="ctr"/>
           <a:lstStyle/>
           <a:p>
-            <a:pPr algn="ctr" indent="0" marL="0">
+            <a:pPr marL="0" indent="0" algn="ctr">
               <a:buNone/>
             </a:pPr>
             <a:r>
@@ -5653,7 +5678,7 @@
             <a:endParaRPr lang="en-US" sz="950" dirty="0"/>
           </a:p>
           <a:p>
-            <a:pPr algn="ctr" indent="0" marL="0">
+            <a:pPr marL="0" indent="0" algn="ctr">
               <a:buNone/>
             </a:pPr>
             <a:r>
@@ -5689,7 +5714,7 @@
           <a:bodyPr wrap="square" lIns="0" tIns="0" rIns="0" bIns="0" rtlCol="0" anchor="ctr"/>
           <a:lstStyle/>
           <a:p>
-            <a:pPr indent="0" marL="0">
+            <a:pPr marL="0" indent="0">
               <a:buNone/>
             </a:pPr>
             <a:r>
@@ -5730,6 +5755,13 @@
             <a:prstDash val="solid"/>
           </a:ln>
         </p:spPr>
+        <p:txBody>
+          <a:bodyPr/>
+          <a:lstStyle/>
+          <a:p>
+            <a:endParaRPr lang="en-US"/>
+          </a:p>
+        </p:txBody>
       </p:sp>
       <p:sp>
         <p:nvSpPr>
@@ -5752,7 +5784,7 @@
           <a:bodyPr wrap="square" lIns="0" tIns="0" rIns="0" bIns="0" rtlCol="0" anchor="ctr"/>
           <a:lstStyle/>
           <a:p>
-            <a:pPr algn="ctr" indent="0" marL="0">
+            <a:pPr marL="0" indent="0" algn="ctr">
               <a:buNone/>
             </a:pPr>
             <a:r>
@@ -5766,7 +5798,7 @@
             <a:endParaRPr lang="en-US" sz="950" dirty="0"/>
           </a:p>
           <a:p>
-            <a:pPr algn="ctr" indent="0" marL="0">
+            <a:pPr marL="0" indent="0" algn="ctr">
               <a:buNone/>
             </a:pPr>
             <a:r>
@@ -5807,6 +5839,13 @@
             <a:prstDash val="solid"/>
           </a:ln>
         </p:spPr>
+        <p:txBody>
+          <a:bodyPr/>
+          <a:lstStyle/>
+          <a:p>
+            <a:endParaRPr lang="en-US"/>
+          </a:p>
+        </p:txBody>
       </p:sp>
       <p:sp>
         <p:nvSpPr>
@@ -5829,7 +5868,7 @@
           <a:bodyPr wrap="square" lIns="0" tIns="0" rIns="0" bIns="0" rtlCol="0" anchor="ctr"/>
           <a:lstStyle/>
           <a:p>
-            <a:pPr algn="ctr" indent="0" marL="0">
+            <a:pPr marL="0" indent="0" algn="ctr">
               <a:buNone/>
             </a:pPr>
             <a:r>
@@ -5843,7 +5882,7 @@
             <a:endParaRPr lang="en-US" sz="950" dirty="0"/>
           </a:p>
           <a:p>
-            <a:pPr algn="ctr" indent="0" marL="0">
+            <a:pPr marL="0" indent="0" algn="ctr">
               <a:buNone/>
             </a:pPr>
             <a:r>
@@ -5879,7 +5918,7 @@
           <a:bodyPr wrap="square" lIns="0" tIns="0" rIns="0" bIns="0" rtlCol="0" anchor="ctr"/>
           <a:lstStyle/>
           <a:p>
-            <a:pPr indent="0" marL="0">
+            <a:pPr marL="0" indent="0">
               <a:buNone/>
             </a:pPr>
             <a:r>
@@ -5920,6 +5959,13 @@
             <a:prstDash val="solid"/>
           </a:ln>
         </p:spPr>
+        <p:txBody>
+          <a:bodyPr/>
+          <a:lstStyle/>
+          <a:p>
+            <a:endParaRPr lang="en-US"/>
+          </a:p>
+        </p:txBody>
       </p:sp>
       <p:sp>
         <p:nvSpPr>
@@ -5942,7 +5988,7 @@
           <a:bodyPr wrap="square" lIns="0" tIns="0" rIns="0" bIns="0" rtlCol="0" anchor="ctr"/>
           <a:lstStyle/>
           <a:p>
-            <a:pPr algn="ctr" indent="0" marL="0">
+            <a:pPr marL="0" indent="0" algn="ctr">
               <a:buNone/>
             </a:pPr>
             <a:r>
@@ -5956,7 +6002,7 @@
             <a:endParaRPr lang="en-US" sz="950" dirty="0"/>
           </a:p>
           <a:p>
-            <a:pPr algn="ctr" indent="0" marL="0">
+            <a:pPr marL="0" indent="0" algn="ctr">
               <a:buNone/>
             </a:pPr>
             <a:r>
@@ -5997,6 +6043,13 @@
             <a:prstDash val="solid"/>
           </a:ln>
         </p:spPr>
+        <p:txBody>
+          <a:bodyPr/>
+          <a:lstStyle/>
+          <a:p>
+            <a:endParaRPr lang="en-US"/>
+          </a:p>
+        </p:txBody>
       </p:sp>
       <p:sp>
         <p:nvSpPr>
@@ -6019,7 +6072,7 @@
           <a:bodyPr wrap="square" lIns="0" tIns="0" rIns="0" bIns="0" rtlCol="0" anchor="ctr"/>
           <a:lstStyle/>
           <a:p>
-            <a:pPr algn="ctr" indent="0" marL="0">
+            <a:pPr marL="0" indent="0" algn="ctr">
               <a:buNone/>
             </a:pPr>
             <a:r>
@@ -6033,7 +6086,7 @@
             <a:endParaRPr lang="en-US" sz="950" dirty="0"/>
           </a:p>
           <a:p>
-            <a:pPr algn="ctr" indent="0" marL="0">
+            <a:pPr marL="0" indent="0" algn="ctr">
               <a:buNone/>
             </a:pPr>
             <a:r>
@@ -6069,7 +6122,7 @@
           <a:bodyPr wrap="square" lIns="0" tIns="0" rIns="0" bIns="0" rtlCol="0" anchor="ctr"/>
           <a:lstStyle/>
           <a:p>
-            <a:pPr indent="0" marL="0">
+            <a:pPr marL="0" indent="0">
               <a:buNone/>
             </a:pPr>
             <a:r>
@@ -6110,6 +6163,13 @@
             <a:prstDash val="solid"/>
           </a:ln>
         </p:spPr>
+        <p:txBody>
+          <a:bodyPr/>
+          <a:lstStyle/>
+          <a:p>
+            <a:endParaRPr lang="en-US"/>
+          </a:p>
+        </p:txBody>
       </p:sp>
       <p:sp>
         <p:nvSpPr>
@@ -6132,7 +6192,7 @@
           <a:bodyPr wrap="square" lIns="0" tIns="0" rIns="0" bIns="0" rtlCol="0" anchor="ctr"/>
           <a:lstStyle/>
           <a:p>
-            <a:pPr algn="ctr" indent="0" marL="0">
+            <a:pPr marL="0" indent="0" algn="ctr">
               <a:buNone/>
             </a:pPr>
             <a:r>
@@ -6146,7 +6206,7 @@
             <a:endParaRPr lang="en-US" sz="950" dirty="0"/>
           </a:p>
           <a:p>
-            <a:pPr algn="ctr" indent="0" marL="0">
+            <a:pPr marL="0" indent="0" algn="ctr">
               <a:buNone/>
             </a:pPr>
             <a:r>
@@ -6187,6 +6247,13 @@
             <a:prstDash val="solid"/>
           </a:ln>
         </p:spPr>
+        <p:txBody>
+          <a:bodyPr/>
+          <a:lstStyle/>
+          <a:p>
+            <a:endParaRPr lang="en-US"/>
+          </a:p>
+        </p:txBody>
       </p:sp>
       <p:sp>
         <p:nvSpPr>
@@ -6209,7 +6276,7 @@
           <a:bodyPr wrap="square" lIns="0" tIns="0" rIns="0" bIns="0" rtlCol="0" anchor="ctr"/>
           <a:lstStyle/>
           <a:p>
-            <a:pPr algn="ctr" indent="0" marL="0">
+            <a:pPr marL="0" indent="0" algn="ctr">
               <a:buNone/>
             </a:pPr>
             <a:r>
@@ -6223,7 +6290,7 @@
             <a:endParaRPr lang="en-US" sz="950" dirty="0"/>
           </a:p>
           <a:p>
-            <a:pPr algn="ctr" indent="0" marL="0">
+            <a:pPr marL="0" indent="0" algn="ctr">
               <a:buNone/>
             </a:pPr>
             <a:r>
@@ -6264,6 +6331,13 @@
             <a:prstDash val="solid"/>
           </a:ln>
         </p:spPr>
+        <p:txBody>
+          <a:bodyPr/>
+          <a:lstStyle/>
+          <a:p>
+            <a:endParaRPr lang="en-US"/>
+          </a:p>
+        </p:txBody>
       </p:sp>
       <p:sp>
         <p:nvSpPr>
@@ -6286,7 +6360,7 @@
           <a:bodyPr wrap="square" lIns="0" tIns="0" rIns="0" bIns="0" rtlCol="0" anchor="ctr"/>
           <a:lstStyle/>
           <a:p>
-            <a:pPr algn="ctr" indent="0" marL="0">
+            <a:pPr marL="0" indent="0" algn="ctr">
               <a:buNone/>
             </a:pPr>
             <a:r>
@@ -6300,7 +6374,7 @@
             <a:endParaRPr lang="en-US" sz="1300" dirty="0"/>
           </a:p>
           <a:p>
-            <a:pPr algn="ctr" indent="0" marL="0">
+            <a:pPr marL="0" indent="0" algn="ctr">
               <a:buNone/>
             </a:pPr>
             <a:r>
@@ -6341,6 +6415,13 @@
             <a:prstDash val="solid"/>
           </a:ln>
         </p:spPr>
+        <p:txBody>
+          <a:bodyPr/>
+          <a:lstStyle/>
+          <a:p>
+            <a:endParaRPr lang="en-US"/>
+          </a:p>
+        </p:txBody>
       </p:sp>
       <p:sp>
         <p:nvSpPr>
@@ -6363,7 +6444,7 @@
           <a:bodyPr wrap="square" lIns="0" tIns="0" rIns="0" bIns="0" rtlCol="0" anchor="ctr"/>
           <a:lstStyle/>
           <a:p>
-            <a:pPr algn="ctr" indent="0" marL="0">
+            <a:pPr marL="0" indent="0" algn="ctr">
               <a:buNone/>
             </a:pPr>
             <a:r>
@@ -6377,7 +6458,7 @@
             <a:endParaRPr lang="en-US" sz="1300" dirty="0"/>
           </a:p>
           <a:p>
-            <a:pPr algn="ctr" indent="0" marL="0">
+            <a:pPr marL="0" indent="0" algn="ctr">
               <a:buNone/>
             </a:pPr>
             <a:r>
@@ -6408,6 +6489,7 @@
         <a:solidFill>
           <a:srgbClr val="FFFFFF"/>
         </a:solidFill>
+        <a:effectLst/>
       </p:bgPr>
     </p:bg>
     <p:spTree>
@@ -6448,6 +6530,13 @@
             <a:prstDash val="solid"/>
           </a:ln>
         </p:spPr>
+        <p:txBody>
+          <a:bodyPr/>
+          <a:lstStyle/>
+          <a:p>
+            <a:endParaRPr lang="en-US"/>
+          </a:p>
+        </p:txBody>
       </p:sp>
       <p:sp>
         <p:nvSpPr>
@@ -6470,7 +6559,7 @@
           <a:bodyPr wrap="square" lIns="0" tIns="0" rIns="0" bIns="0" rtlCol="0" anchor="ctr"/>
           <a:lstStyle/>
           <a:p>
-            <a:pPr indent="0" marL="0">
+            <a:pPr marL="0" indent="0">
               <a:buNone/>
             </a:pPr>
             <a:r>
@@ -6509,7 +6598,7 @@
           <a:bodyPr wrap="square" lIns="0" tIns="0" rIns="0" bIns="0" rtlCol="0" anchor="ctr"/>
           <a:lstStyle/>
           <a:p>
-            <a:pPr algn="r" indent="0" marL="0">
+            <a:pPr marL="0" indent="0" algn="r">
               <a:buNone/>
             </a:pPr>
             <a:r>
@@ -6545,7 +6634,7 @@
           <a:bodyPr wrap="square" lIns="0" tIns="0" rIns="0" bIns="0" rtlCol="0" anchor="ctr"/>
           <a:lstStyle/>
           <a:p>
-            <a:pPr algn="r" indent="0" marL="0">
+            <a:pPr marL="0" indent="0" algn="r">
               <a:buNone/>
             </a:pPr>
             <a:r>
@@ -6557,69 +6646,87 @@
               <a:t>Cache Controller | Verilog RTL | 4/12</a:t>
             </a:r>
             <a:endParaRPr lang="en-US" sz="750" dirty="0"/>
+          </a:p>
+        </p:txBody>
+      </p:sp>
+      <p:sp>
+        <p:nvSpPr>
+          <p:cNvPr id="7" name="Text 4"/>
+          <p:cNvSpPr/>
+          <p:nvPr/>
+        </p:nvSpPr>
+        <p:spPr>
+          <a:xfrm>
+            <a:off x="914400" y="6263640"/>
+            <a:ext cx="10424160" cy="201168"/>
+          </a:xfrm>
+          <a:prstGeom prst="rect">
+            <a:avLst/>
+          </a:prstGeom>
+          <a:noFill/>
+          <a:ln/>
+        </p:spPr>
+        <p:txBody>
+          <a:bodyPr wrap="square" lIns="0" tIns="0" rIns="0" bIns="0" rtlCol="0" anchor="ctr"/>
+          <a:lstStyle/>
+          <a:p>
+            <a:pPr marL="0" indent="0" algn="ctr">
+              <a:buNone/>
+            </a:pPr>
+            <a:r>
+              <a:rPr lang="en-US" sz="1300" i="1" dirty="0">
+                <a:solidFill>
+                  <a:srgbClr val="5C6770"/>
+                </a:solidFill>
+              </a:rPr>
+              <a:t>Testbench → CPU model → cache controller → main memory</a:t>
+            </a:r>
+            <a:endParaRPr lang="en-US" sz="1300" dirty="0"/>
           </a:p>
         </p:txBody>
       </p:sp>
       <p:pic>
         <p:nvPicPr>
-          <p:cNvPr id="6" name="Image 0" descr="/mnt/data/report_extract/word/media/image1.png">    </p:cNvPr>
+          <p:cNvPr id="9" name="Picture 8">
+            <a:extLst>
+              <a:ext uri="{FF2B5EF4-FFF2-40B4-BE49-F238E27FC236}">
+                <a16:creationId xmlns:a16="http://schemas.microsoft.com/office/drawing/2014/main" id="{B8BBBEBB-DDE5-56BA-E7CB-C2E82BEC9097}"/>
+              </a:ext>
+            </a:extLst>
+          </p:cNvPr>
           <p:cNvPicPr>
             <a:picLocks noChangeAspect="1"/>
           </p:cNvPicPr>
           <p:nvPr/>
         </p:nvPicPr>
         <p:blipFill>
-          <a:blip r:embed="rId1"/>
+          <a:blip r:embed="rId3"/>
           <a:stretch>
             <a:fillRect/>
           </a:stretch>
         </p:blipFill>
         <p:spPr>
           <a:xfrm>
-            <a:off x="2598420" y="868680"/>
-            <a:ext cx="7010400" cy="5257800"/>
-          </a:xfrm>
-          <a:prstGeom prst="rect">
-            <a:avLst/>
-          </a:prstGeom>
+            <a:off x="1356360" y="753539"/>
+            <a:ext cx="9540240" cy="5350922"/>
+          </a:xfrm>
+          <a:prstGeom prst="rect">
+            <a:avLst/>
+          </a:prstGeom>
+          <a:ln w="19050">
+            <a:solidFill>
+              <a:schemeClr val="tx1"/>
+            </a:solidFill>
+          </a:ln>
+          <a:effectLst>
+            <a:outerShdw blurRad="292100" dist="139700" dir="2700000" algn="tl" rotWithShape="0">
+              <a:srgbClr val="333333">
+                <a:alpha val="65000"/>
+              </a:srgbClr>
+            </a:outerShdw>
+          </a:effectLst>
         </p:spPr>
       </p:pic>
-      <p:sp>
-        <p:nvSpPr>
-          <p:cNvPr id="7" name="Text 4"/>
-          <p:cNvSpPr/>
-          <p:nvPr/>
-        </p:nvSpPr>
-        <p:spPr>
-          <a:xfrm>
-            <a:off x="914400" y="6263640"/>
-            <a:ext cx="10424160" cy="201168"/>
-          </a:xfrm>
-          <a:prstGeom prst="rect">
-            <a:avLst/>
-          </a:prstGeom>
-          <a:noFill/>
-          <a:ln/>
-        </p:spPr>
-        <p:txBody>
-          <a:bodyPr wrap="square" lIns="0" tIns="0" rIns="0" bIns="0" rtlCol="0" anchor="ctr"/>
-          <a:lstStyle/>
-          <a:p>
-            <a:pPr algn="ctr" indent="0" marL="0">
-              <a:buNone/>
-            </a:pPr>
-            <a:r>
-              <a:rPr lang="en-US" sz="1300" i="1" dirty="0">
-                <a:solidFill>
-                  <a:srgbClr val="5C6770"/>
-                </a:solidFill>
-              </a:rPr>
-              <a:t>Testbench → CPU model → cache controller → main memory</a:t>
-            </a:r>
-            <a:endParaRPr lang="en-US" sz="1300" dirty="0"/>
-          </a:p>
-        </p:txBody>
-      </p:sp>
     </p:spTree>
   </p:cSld>
   <p:clrMapOvr>
@@ -6636,6 +6743,7 @@
         <a:solidFill>
           <a:srgbClr val="FFFFFF"/>
         </a:solidFill>
+        <a:effectLst/>
       </p:bgPr>
     </p:bg>
     <p:spTree>
@@ -6676,6 +6784,13 @@
             <a:prstDash val="solid"/>
           </a:ln>
         </p:spPr>
+        <p:txBody>
+          <a:bodyPr/>
+          <a:lstStyle/>
+          <a:p>
+            <a:endParaRPr lang="en-US"/>
+          </a:p>
+        </p:txBody>
       </p:sp>
       <p:sp>
         <p:nvSpPr>
@@ -6698,7 +6813,7 @@
           <a:bodyPr wrap="square" lIns="0" tIns="0" rIns="0" bIns="0" rtlCol="0" anchor="ctr"/>
           <a:lstStyle/>
           <a:p>
-            <a:pPr indent="0" marL="0">
+            <a:pPr marL="0" indent="0">
               <a:buNone/>
             </a:pPr>
             <a:r>
@@ -6737,7 +6852,7 @@
           <a:bodyPr wrap="square" lIns="0" tIns="0" rIns="0" bIns="0" rtlCol="0" anchor="ctr"/>
           <a:lstStyle/>
           <a:p>
-            <a:pPr algn="r" indent="0" marL="0">
+            <a:pPr marL="0" indent="0" algn="r">
               <a:buNone/>
             </a:pPr>
             <a:r>
@@ -6773,7 +6888,7 @@
           <a:bodyPr wrap="square" lIns="0" tIns="0" rIns="0" bIns="0" rtlCol="0" anchor="ctr"/>
           <a:lstStyle/>
           <a:p>
-            <a:pPr algn="r" indent="0" marL="0">
+            <a:pPr marL="0" indent="0" algn="r">
               <a:buNone/>
             </a:pPr>
             <a:r>
@@ -6811,6 +6926,13 @@
             <a:tailEnd type="triangle"/>
           </a:ln>
         </p:spPr>
+        <p:txBody>
+          <a:bodyPr/>
+          <a:lstStyle/>
+          <a:p>
+            <a:endParaRPr lang="en-US"/>
+          </a:p>
+        </p:txBody>
       </p:sp>
       <p:sp>
         <p:nvSpPr>
@@ -6835,6 +6957,13 @@
             <a:tailEnd type="triangle"/>
           </a:ln>
         </p:spPr>
+        <p:txBody>
+          <a:bodyPr/>
+          <a:lstStyle/>
+          <a:p>
+            <a:endParaRPr lang="en-US"/>
+          </a:p>
+        </p:txBody>
       </p:sp>
       <p:sp>
         <p:nvSpPr>
@@ -6859,6 +6988,13 @@
             <a:tailEnd type="triangle"/>
           </a:ln>
         </p:spPr>
+        <p:txBody>
+          <a:bodyPr/>
+          <a:lstStyle/>
+          <a:p>
+            <a:endParaRPr lang="en-US"/>
+          </a:p>
+        </p:txBody>
       </p:sp>
       <p:sp>
         <p:nvSpPr>
@@ -6886,6 +7022,13 @@
             <a:prstDash val="solid"/>
           </a:ln>
         </p:spPr>
+        <p:txBody>
+          <a:bodyPr/>
+          <a:lstStyle/>
+          <a:p>
+            <a:endParaRPr lang="en-US"/>
+          </a:p>
+        </p:txBody>
       </p:sp>
       <p:sp>
         <p:nvSpPr>
@@ -6908,7 +7051,7 @@
           <a:bodyPr wrap="square" lIns="0" tIns="0" rIns="0" bIns="0" rtlCol="0" anchor="ctr"/>
           <a:lstStyle/>
           <a:p>
-            <a:pPr algn="ctr" indent="0" marL="0">
+            <a:pPr marL="0" indent="0" algn="ctr">
               <a:buNone/>
             </a:pPr>
             <a:r>
@@ -6946,7 +7089,7 @@
           </a:bodyPr>
           <a:lstStyle/>
           <a:p>
-            <a:pPr algn="ctr" indent="0" marL="0">
+            <a:pPr marL="0" indent="0" algn="ctr">
               <a:buNone/>
             </a:pPr>
             <a:r>
@@ -6955,12 +7098,12 @@
                   <a:srgbClr val="111111"/>
                 </a:solidFill>
               </a:rPr>
-              <a:t>CPU-side adapter</a:t>
+              <a:t>CPU-side</a:t>
             </a:r>
             <a:endParaRPr lang="en-US" sz="1200" dirty="0"/>
           </a:p>
           <a:p>
-            <a:pPr algn="ctr" indent="0" marL="0">
+            <a:pPr marL="0" indent="0" algn="ctr">
               <a:buNone/>
             </a:pPr>
             <a:r>
@@ -6974,7 +7117,7 @@
             <a:endParaRPr lang="en-US" sz="1200" dirty="0"/>
           </a:p>
           <a:p>
-            <a:pPr algn="ctr" indent="0" marL="0">
+            <a:pPr marL="0" indent="0" algn="ctr">
               <a:buNone/>
             </a:pPr>
             <a:r>
@@ -7015,6 +7158,13 @@
             <a:prstDash val="solid"/>
           </a:ln>
         </p:spPr>
+        <p:txBody>
+          <a:bodyPr/>
+          <a:lstStyle/>
+          <a:p>
+            <a:endParaRPr lang="en-US"/>
+          </a:p>
+        </p:txBody>
       </p:sp>
       <p:sp>
         <p:nvSpPr>
@@ -7037,7 +7187,7 @@
           <a:bodyPr wrap="square" lIns="0" tIns="0" rIns="0" bIns="0" rtlCol="0" anchor="ctr"/>
           <a:lstStyle/>
           <a:p>
-            <a:pPr algn="ctr" indent="0" marL="0">
+            <a:pPr marL="0" indent="0" algn="ctr">
               <a:buNone/>
             </a:pPr>
             <a:r>
@@ -7075,7 +7225,7 @@
           </a:bodyPr>
           <a:lstStyle/>
           <a:p>
-            <a:pPr algn="ctr" indent="0" marL="0">
+            <a:pPr marL="0" indent="0" algn="ctr">
               <a:buNone/>
             </a:pPr>
             <a:r>
@@ -7089,7 +7239,7 @@
             <a:endParaRPr lang="en-US" sz="1200" dirty="0"/>
           </a:p>
           <a:p>
-            <a:pPr algn="ctr" indent="0" marL="0">
+            <a:pPr marL="0" indent="0" algn="ctr">
               <a:buNone/>
             </a:pPr>
             <a:r>
@@ -7103,7 +7253,7 @@
             <a:endParaRPr lang="en-US" sz="1200" dirty="0"/>
           </a:p>
           <a:p>
-            <a:pPr algn="ctr" indent="0" marL="0">
+            <a:pPr marL="0" indent="0" algn="ctr">
               <a:buNone/>
             </a:pPr>
             <a:r>
@@ -7144,6 +7294,13 @@
             <a:prstDash val="solid"/>
           </a:ln>
         </p:spPr>
+        <p:txBody>
+          <a:bodyPr/>
+          <a:lstStyle/>
+          <a:p>
+            <a:endParaRPr lang="en-US"/>
+          </a:p>
+        </p:txBody>
       </p:sp>
       <p:sp>
         <p:nvSpPr>
@@ -7166,7 +7323,7 @@
           <a:bodyPr wrap="square" lIns="0" tIns="0" rIns="0" bIns="0" rtlCol="0" anchor="ctr"/>
           <a:lstStyle/>
           <a:p>
-            <a:pPr algn="ctr" indent="0" marL="0">
+            <a:pPr marL="0" indent="0" algn="ctr">
               <a:buNone/>
             </a:pPr>
             <a:r>
@@ -7204,7 +7361,7 @@
           </a:bodyPr>
           <a:lstStyle/>
           <a:p>
-            <a:pPr algn="ctr" indent="0" marL="0">
+            <a:pPr marL="0" indent="0" algn="ctr">
               <a:buNone/>
             </a:pPr>
             <a:r>
@@ -7218,7 +7375,7 @@
             <a:endParaRPr lang="en-US" sz="1200" dirty="0"/>
           </a:p>
           <a:p>
-            <a:pPr algn="ctr" indent="0" marL="0">
+            <a:pPr marL="0" indent="0" algn="ctr">
               <a:buNone/>
             </a:pPr>
             <a:r>
@@ -7232,7 +7389,7 @@
             <a:endParaRPr lang="en-US" sz="1200" dirty="0"/>
           </a:p>
           <a:p>
-            <a:pPr algn="ctr" indent="0" marL="0">
+            <a:pPr marL="0" indent="0" algn="ctr">
               <a:buNone/>
             </a:pPr>
             <a:r>
@@ -7273,6 +7430,13 @@
             <a:prstDash val="solid"/>
           </a:ln>
         </p:spPr>
+        <p:txBody>
+          <a:bodyPr/>
+          <a:lstStyle/>
+          <a:p>
+            <a:endParaRPr lang="en-US"/>
+          </a:p>
+        </p:txBody>
       </p:sp>
       <p:sp>
         <p:nvSpPr>
@@ -7295,7 +7459,7 @@
           <a:bodyPr wrap="square" lIns="0" tIns="0" rIns="0" bIns="0" rtlCol="0" anchor="ctr"/>
           <a:lstStyle/>
           <a:p>
-            <a:pPr algn="ctr" indent="0" marL="0">
+            <a:pPr marL="0" indent="0" algn="ctr">
               <a:buNone/>
             </a:pPr>
             <a:r>
@@ -7333,7 +7497,7 @@
           </a:bodyPr>
           <a:lstStyle/>
           <a:p>
-            <a:pPr algn="ctr" indent="0" marL="0">
+            <a:pPr marL="0" indent="0" algn="ctr">
               <a:buNone/>
             </a:pPr>
             <a:r>
@@ -7347,7 +7511,7 @@
             <a:endParaRPr lang="en-US" sz="1200" dirty="0"/>
           </a:p>
           <a:p>
-            <a:pPr algn="ctr" indent="0" marL="0">
+            <a:pPr marL="0" indent="0" algn="ctr">
               <a:buNone/>
             </a:pPr>
             <a:r>
@@ -7383,7 +7547,7 @@
           <a:bodyPr wrap="square" lIns="0" tIns="0" rIns="0" bIns="0" rtlCol="0" anchor="ctr"/>
           <a:lstStyle/>
           <a:p>
-            <a:pPr indent="0" marL="0">
+            <a:pPr marL="0" indent="0">
               <a:buNone/>
             </a:pPr>
             <a:r>
@@ -7481,6 +7645,13 @@
             <a:prstDash val="solid"/>
           </a:ln>
         </p:spPr>
+        <p:txBody>
+          <a:bodyPr/>
+          <a:lstStyle/>
+          <a:p>
+            <a:endParaRPr lang="en-US"/>
+          </a:p>
+        </p:txBody>
       </p:sp>
       <p:sp>
         <p:nvSpPr>
@@ -7503,7 +7674,7 @@
           <a:bodyPr wrap="square" lIns="0" tIns="0" rIns="0" bIns="0" rtlCol="0" anchor="ctr"/>
           <a:lstStyle/>
           <a:p>
-            <a:pPr algn="ctr" indent="0" marL="0">
+            <a:pPr marL="0" indent="0" algn="ctr">
               <a:buNone/>
             </a:pPr>
             <a:r>
@@ -7517,7 +7688,7 @@
             <a:endParaRPr lang="en-US" sz="1250" dirty="0"/>
           </a:p>
           <a:p>
-            <a:pPr algn="ctr" indent="0" marL="0">
+            <a:pPr marL="0" indent="0" algn="ctr">
               <a:buNone/>
             </a:pPr>
             <a:r>
@@ -7548,6 +7719,7 @@
         <a:solidFill>
           <a:srgbClr val="FFFFFF"/>
         </a:solidFill>
+        <a:effectLst/>
       </p:bgPr>
     </p:bg>
     <p:spTree>
@@ -7588,6 +7760,13 @@
             <a:prstDash val="solid"/>
           </a:ln>
         </p:spPr>
+        <p:txBody>
+          <a:bodyPr/>
+          <a:lstStyle/>
+          <a:p>
+            <a:endParaRPr lang="en-US"/>
+          </a:p>
+        </p:txBody>
       </p:sp>
       <p:sp>
         <p:nvSpPr>
@@ -7610,7 +7789,7 @@
           <a:bodyPr wrap="square" lIns="0" tIns="0" rIns="0" bIns="0" rtlCol="0" anchor="ctr"/>
           <a:lstStyle/>
           <a:p>
-            <a:pPr indent="0" marL="0">
+            <a:pPr marL="0" indent="0">
               <a:buNone/>
             </a:pPr>
             <a:r>
@@ -7649,7 +7828,7 @@
           <a:bodyPr wrap="square" lIns="0" tIns="0" rIns="0" bIns="0" rtlCol="0" anchor="ctr"/>
           <a:lstStyle/>
           <a:p>
-            <a:pPr algn="r" indent="0" marL="0">
+            <a:pPr marL="0" indent="0" algn="r">
               <a:buNone/>
             </a:pPr>
             <a:r>
@@ -7685,7 +7864,7 @@
           <a:bodyPr wrap="square" lIns="0" tIns="0" rIns="0" bIns="0" rtlCol="0" anchor="ctr"/>
           <a:lstStyle/>
           <a:p>
-            <a:pPr algn="r" indent="0" marL="0">
+            <a:pPr marL="0" indent="0" algn="r">
               <a:buNone/>
             </a:pPr>
             <a:r>
@@ -7702,14 +7881,14 @@
       </p:sp>
       <p:pic>
         <p:nvPicPr>
-          <p:cNvPr id="6" name="Image 0" descr="/mnt/data/report_extract/word/media/image2.png">    </p:cNvPr>
+          <p:cNvPr id="6" name="Image 0" descr="/mnt/data/report_extract/word/media/image2.png"/>
           <p:cNvPicPr>
             <a:picLocks noChangeAspect="1"/>
           </p:cNvPicPr>
           <p:nvPr/>
         </p:nvPicPr>
         <p:blipFill>
-          <a:blip r:embed="rId1"/>
+          <a:blip r:embed="rId3"/>
           <a:stretch>
             <a:fillRect/>
           </a:stretch>
@@ -7745,7 +7924,7 @@
           <a:bodyPr wrap="square" lIns="0" tIns="0" rIns="0" bIns="0" rtlCol="0" anchor="ctr"/>
           <a:lstStyle/>
           <a:p>
-            <a:pPr indent="0" marL="0">
+            <a:pPr marL="0" indent="0">
               <a:buNone/>
             </a:pPr>
             <a:r>
@@ -7854,6 +8033,13 @@
             <a:prstDash val="solid"/>
           </a:ln>
         </p:spPr>
+        <p:txBody>
+          <a:bodyPr/>
+          <a:lstStyle/>
+          <a:p>
+            <a:endParaRPr lang="en-US"/>
+          </a:p>
+        </p:txBody>
       </p:sp>
       <p:sp>
         <p:nvSpPr>
@@ -7876,7 +8062,7 @@
           <a:bodyPr wrap="square" lIns="0" tIns="0" rIns="0" bIns="0" rtlCol="0" anchor="ctr"/>
           <a:lstStyle/>
           <a:p>
-            <a:pPr algn="ctr" indent="0" marL="0">
+            <a:pPr marL="0" indent="0" algn="ctr">
               <a:buNone/>
             </a:pPr>
             <a:r>
@@ -7917,6 +8103,13 @@
             <a:prstDash val="solid"/>
           </a:ln>
         </p:spPr>
+        <p:txBody>
+          <a:bodyPr/>
+          <a:lstStyle/>
+          <a:p>
+            <a:endParaRPr lang="en-US"/>
+          </a:p>
+        </p:txBody>
       </p:sp>
       <p:sp>
         <p:nvSpPr>
@@ -7939,7 +8132,7 @@
           <a:bodyPr wrap="square" lIns="0" tIns="0" rIns="0" bIns="0" rtlCol="0" anchor="ctr"/>
           <a:lstStyle/>
           <a:p>
-            <a:pPr algn="ctr" indent="0" marL="0">
+            <a:pPr marL="0" indent="0" algn="ctr">
               <a:buNone/>
             </a:pPr>
             <a:r>
@@ -7970,6 +8163,7 @@
         <a:solidFill>
           <a:srgbClr val="FFFFFF"/>
         </a:solidFill>
+        <a:effectLst/>
       </p:bgPr>
     </p:bg>
     <p:spTree>
@@ -8010,6 +8204,13 @@
             <a:prstDash val="solid"/>
           </a:ln>
         </p:spPr>
+        <p:txBody>
+          <a:bodyPr/>
+          <a:lstStyle/>
+          <a:p>
+            <a:endParaRPr lang="en-US"/>
+          </a:p>
+        </p:txBody>
       </p:sp>
       <p:sp>
         <p:nvSpPr>
@@ -8032,7 +8233,7 @@
           <a:bodyPr wrap="square" lIns="0" tIns="0" rIns="0" bIns="0" rtlCol="0" anchor="ctr"/>
           <a:lstStyle/>
           <a:p>
-            <a:pPr indent="0" marL="0">
+            <a:pPr marL="0" indent="0">
               <a:buNone/>
             </a:pPr>
             <a:r>
@@ -8071,7 +8272,7 @@
           <a:bodyPr wrap="square" lIns="0" tIns="0" rIns="0" bIns="0" rtlCol="0" anchor="ctr"/>
           <a:lstStyle/>
           <a:p>
-            <a:pPr algn="r" indent="0" marL="0">
+            <a:pPr marL="0" indent="0" algn="r">
               <a:buNone/>
             </a:pPr>
             <a:r>
@@ -8107,7 +8308,7 @@
           <a:bodyPr wrap="square" lIns="0" tIns="0" rIns="0" bIns="0" rtlCol="0" anchor="ctr"/>
           <a:lstStyle/>
           <a:p>
-            <a:pPr algn="r" indent="0" marL="0">
+            <a:pPr marL="0" indent="0" algn="r">
               <a:buNone/>
             </a:pPr>
             <a:r>
@@ -8143,7 +8344,7 @@
           <a:bodyPr wrap="square" lIns="0" tIns="0" rIns="0" bIns="0" rtlCol="0" anchor="ctr"/>
           <a:lstStyle/>
           <a:p>
-            <a:pPr indent="0" marL="0">
+            <a:pPr marL="0" indent="0">
               <a:buNone/>
             </a:pPr>
             <a:r>
@@ -8179,7 +8380,7 @@
           <a:bodyPr wrap="square" lIns="0" tIns="0" rIns="0" bIns="0" rtlCol="0" anchor="ctr"/>
           <a:lstStyle/>
           <a:p>
-            <a:pPr indent="0" marL="0">
+            <a:pPr marL="0" indent="0">
               <a:buNone/>
             </a:pPr>
             <a:r>
@@ -8217,6 +8418,13 @@
             <a:tailEnd type="triangle"/>
           </a:ln>
         </p:spPr>
+        <p:txBody>
+          <a:bodyPr/>
+          <a:lstStyle/>
+          <a:p>
+            <a:endParaRPr lang="en-US"/>
+          </a:p>
+        </p:txBody>
       </p:sp>
       <p:sp>
         <p:nvSpPr>
@@ -8241,6 +8449,13 @@
             <a:tailEnd type="triangle"/>
           </a:ln>
         </p:spPr>
+        <p:txBody>
+          <a:bodyPr/>
+          <a:lstStyle/>
+          <a:p>
+            <a:endParaRPr lang="en-US"/>
+          </a:p>
+        </p:txBody>
       </p:sp>
       <p:sp>
         <p:nvSpPr>
@@ -8265,6 +8480,13 @@
             <a:tailEnd type="triangle"/>
           </a:ln>
         </p:spPr>
+        <p:txBody>
+          <a:bodyPr/>
+          <a:lstStyle/>
+          <a:p>
+            <a:endParaRPr lang="en-US"/>
+          </a:p>
+        </p:txBody>
       </p:sp>
       <p:sp>
         <p:nvSpPr>
@@ -8289,6 +8511,13 @@
             <a:tailEnd type="triangle"/>
           </a:ln>
         </p:spPr>
+        <p:txBody>
+          <a:bodyPr/>
+          <a:lstStyle/>
+          <a:p>
+            <a:endParaRPr lang="en-US"/>
+          </a:p>
+        </p:txBody>
       </p:sp>
       <p:sp>
         <p:nvSpPr>
@@ -8313,6 +8542,13 @@
             <a:tailEnd type="triangle"/>
           </a:ln>
         </p:spPr>
+        <p:txBody>
+          <a:bodyPr/>
+          <a:lstStyle/>
+          <a:p>
+            <a:endParaRPr lang="en-US"/>
+          </a:p>
+        </p:txBody>
       </p:sp>
       <p:sp>
         <p:nvSpPr>
@@ -8340,6 +8576,13 @@
             <a:prstDash val="solid"/>
           </a:ln>
         </p:spPr>
+        <p:txBody>
+          <a:bodyPr/>
+          <a:lstStyle/>
+          <a:p>
+            <a:endParaRPr lang="en-US"/>
+          </a:p>
+        </p:txBody>
       </p:sp>
       <p:sp>
         <p:nvSpPr>
@@ -8362,7 +8605,7 @@
           <a:bodyPr wrap="square" lIns="0" tIns="0" rIns="0" bIns="0" rtlCol="0" anchor="ctr"/>
           <a:lstStyle/>
           <a:p>
-            <a:pPr algn="ctr" indent="0" marL="0">
+            <a:pPr marL="0" indent="0" algn="ctr">
               <a:buNone/>
             </a:pPr>
             <a:r>
@@ -8376,7 +8619,7 @@
             <a:endParaRPr lang="en-US" sz="1200" dirty="0"/>
           </a:p>
           <a:p>
-            <a:pPr algn="ctr" indent="0" marL="0">
+            <a:pPr marL="0" indent="0" algn="ctr">
               <a:buNone/>
             </a:pPr>
             <a:r>
@@ -8417,6 +8660,13 @@
             <a:prstDash val="solid"/>
           </a:ln>
         </p:spPr>
+        <p:txBody>
+          <a:bodyPr/>
+          <a:lstStyle/>
+          <a:p>
+            <a:endParaRPr lang="en-US"/>
+          </a:p>
+        </p:txBody>
       </p:sp>
       <p:sp>
         <p:nvSpPr>
@@ -8439,7 +8689,7 @@
           <a:bodyPr wrap="square" lIns="0" tIns="0" rIns="0" bIns="0" rtlCol="0" anchor="ctr"/>
           <a:lstStyle/>
           <a:p>
-            <a:pPr algn="ctr" indent="0" marL="0">
+            <a:pPr marL="0" indent="0" algn="ctr">
               <a:buNone/>
             </a:pPr>
             <a:r>
@@ -8453,7 +8703,7 @@
             <a:endParaRPr lang="en-US" sz="1200" dirty="0"/>
           </a:p>
           <a:p>
-            <a:pPr algn="ctr" indent="0" marL="0">
+            <a:pPr marL="0" indent="0" algn="ctr">
               <a:buNone/>
             </a:pPr>
             <a:r>
@@ -8494,6 +8744,13 @@
             <a:prstDash val="solid"/>
           </a:ln>
         </p:spPr>
+        <p:txBody>
+          <a:bodyPr/>
+          <a:lstStyle/>
+          <a:p>
+            <a:endParaRPr lang="en-US"/>
+          </a:p>
+        </p:txBody>
       </p:sp>
       <p:sp>
         <p:nvSpPr>
@@ -8516,7 +8773,7 @@
           <a:bodyPr wrap="square" lIns="0" tIns="0" rIns="0" bIns="0" rtlCol="0" anchor="ctr"/>
           <a:lstStyle/>
           <a:p>
-            <a:pPr algn="ctr" indent="0" marL="0">
+            <a:pPr marL="0" indent="0" algn="ctr">
               <a:buNone/>
             </a:pPr>
             <a:r>
@@ -8530,7 +8787,7 @@
             <a:endParaRPr lang="en-US" sz="1200" dirty="0"/>
           </a:p>
           <a:p>
-            <a:pPr algn="ctr" indent="0" marL="0">
+            <a:pPr marL="0" indent="0" algn="ctr">
               <a:buNone/>
             </a:pPr>
             <a:r>
@@ -8571,6 +8828,13 @@
             <a:prstDash val="solid"/>
           </a:ln>
         </p:spPr>
+        <p:txBody>
+          <a:bodyPr/>
+          <a:lstStyle/>
+          <a:p>
+            <a:endParaRPr lang="en-US"/>
+          </a:p>
+        </p:txBody>
       </p:sp>
       <p:sp>
         <p:nvSpPr>
@@ -8593,7 +8857,7 @@
           <a:bodyPr wrap="square" lIns="0" tIns="0" rIns="0" bIns="0" rtlCol="0" anchor="ctr"/>
           <a:lstStyle/>
           <a:p>
-            <a:pPr algn="ctr" indent="0" marL="0">
+            <a:pPr marL="0" indent="0" algn="ctr">
               <a:buNone/>
             </a:pPr>
             <a:r>
@@ -8607,7 +8871,7 @@
             <a:endParaRPr lang="en-US" sz="1200" dirty="0"/>
           </a:p>
           <a:p>
-            <a:pPr algn="ctr" indent="0" marL="0">
+            <a:pPr marL="0" indent="0" algn="ctr">
               <a:buNone/>
             </a:pPr>
             <a:r>
@@ -8648,6 +8912,13 @@
             <a:prstDash val="solid"/>
           </a:ln>
         </p:spPr>
+        <p:txBody>
+          <a:bodyPr/>
+          <a:lstStyle/>
+          <a:p>
+            <a:endParaRPr lang="en-US"/>
+          </a:p>
+        </p:txBody>
       </p:sp>
       <p:sp>
         <p:nvSpPr>
@@ -8670,7 +8941,7 @@
           <a:bodyPr wrap="square" lIns="0" tIns="0" rIns="0" bIns="0" rtlCol="0" anchor="ctr"/>
           <a:lstStyle/>
           <a:p>
-            <a:pPr algn="ctr" indent="0" marL="0">
+            <a:pPr marL="0" indent="0" algn="ctr">
               <a:buNone/>
             </a:pPr>
             <a:r>
@@ -8684,7 +8955,7 @@
             <a:endParaRPr lang="en-US" sz="1200" dirty="0"/>
           </a:p>
           <a:p>
-            <a:pPr algn="ctr" indent="0" marL="0">
+            <a:pPr marL="0" indent="0" algn="ctr">
               <a:buNone/>
             </a:pPr>
             <a:r>
@@ -8725,6 +8996,13 @@
             <a:prstDash val="solid"/>
           </a:ln>
         </p:spPr>
+        <p:txBody>
+          <a:bodyPr/>
+          <a:lstStyle/>
+          <a:p>
+            <a:endParaRPr lang="en-US"/>
+          </a:p>
+        </p:txBody>
       </p:sp>
       <p:sp>
         <p:nvSpPr>
@@ -8747,7 +9025,7 @@
           <a:bodyPr wrap="square" lIns="0" tIns="0" rIns="0" bIns="0" rtlCol="0" anchor="ctr"/>
           <a:lstStyle/>
           <a:p>
-            <a:pPr algn="ctr" indent="0" marL="0">
+            <a:pPr marL="0" indent="0" algn="ctr">
               <a:buNone/>
             </a:pPr>
             <a:r>
@@ -8761,7 +9039,7 @@
             <a:endParaRPr lang="en-US" sz="1200" dirty="0"/>
           </a:p>
           <a:p>
-            <a:pPr algn="ctr" indent="0" marL="0">
+            <a:pPr marL="0" indent="0" algn="ctr">
               <a:buNone/>
             </a:pPr>
             <a:r>
@@ -8802,6 +9080,13 @@
             <a:prstDash val="solid"/>
           </a:ln>
         </p:spPr>
+        <p:txBody>
+          <a:bodyPr/>
+          <a:lstStyle/>
+          <a:p>
+            <a:endParaRPr lang="en-US"/>
+          </a:p>
+        </p:txBody>
       </p:sp>
       <p:sp>
         <p:nvSpPr>
@@ -8824,7 +9109,7 @@
           <a:bodyPr wrap="square" lIns="0" tIns="0" rIns="0" bIns="0" rtlCol="0" anchor="ctr"/>
           <a:lstStyle/>
           <a:p>
-            <a:pPr algn="ctr" indent="0" marL="0">
+            <a:pPr marL="0" indent="0" algn="ctr">
               <a:buNone/>
             </a:pPr>
             <a:r>
@@ -8838,7 +9123,7 @@
             <a:endParaRPr lang="en-US" sz="1200" dirty="0"/>
           </a:p>
           <a:p>
-            <a:pPr algn="ctr" indent="0" marL="0">
+            <a:pPr marL="0" indent="0" algn="ctr">
               <a:buNone/>
             </a:pPr>
             <a:r>
@@ -8874,7 +9159,7 @@
           <a:bodyPr wrap="square" lIns="0" tIns="0" rIns="0" bIns="0" rtlCol="0" anchor="ctr"/>
           <a:lstStyle/>
           <a:p>
-            <a:pPr indent="0" marL="0">
+            <a:pPr marL="0" indent="0">
               <a:buNone/>
             </a:pPr>
             <a:r>
@@ -8910,7 +9195,7 @@
           <a:bodyPr wrap="square" lIns="0" tIns="0" rIns="0" bIns="0" rtlCol="0" anchor="ctr"/>
           <a:lstStyle/>
           <a:p>
-            <a:pPr indent="0" marL="0">
+            <a:pPr marL="0" indent="0">
               <a:buNone/>
             </a:pPr>
             <a:r>
@@ -8941,6 +9226,7 @@
         <a:solidFill>
           <a:srgbClr val="FFFFFF"/>
         </a:solidFill>
+        <a:effectLst/>
       </p:bgPr>
     </p:bg>
     <p:spTree>
@@ -8981,6 +9267,13 @@
             <a:prstDash val="solid"/>
           </a:ln>
         </p:spPr>
+        <p:txBody>
+          <a:bodyPr/>
+          <a:lstStyle/>
+          <a:p>
+            <a:endParaRPr lang="en-US"/>
+          </a:p>
+        </p:txBody>
       </p:sp>
       <p:sp>
         <p:nvSpPr>
@@ -9003,7 +9296,7 @@
           <a:bodyPr wrap="square" lIns="0" tIns="0" rIns="0" bIns="0" rtlCol="0" anchor="ctr"/>
           <a:lstStyle/>
           <a:p>
-            <a:pPr indent="0" marL="0">
+            <a:pPr marL="0" indent="0">
               <a:buNone/>
             </a:pPr>
             <a:r>
@@ -9042,7 +9335,7 @@
           <a:bodyPr wrap="square" lIns="0" tIns="0" rIns="0" bIns="0" rtlCol="0" anchor="ctr"/>
           <a:lstStyle/>
           <a:p>
-            <a:pPr algn="r" indent="0" marL="0">
+            <a:pPr marL="0" indent="0" algn="r">
               <a:buNone/>
             </a:pPr>
             <a:r>
@@ -9078,7 +9371,7 @@
           <a:bodyPr wrap="square" lIns="0" tIns="0" rIns="0" bIns="0" rtlCol="0" anchor="ctr"/>
           <a:lstStyle/>
           <a:p>
-            <a:pPr algn="r" indent="0" marL="0">
+            <a:pPr marL="0" indent="0" algn="r">
               <a:buNone/>
             </a:pPr>
             <a:r>
@@ -9114,7 +9407,7 @@
           <a:bodyPr wrap="square" lIns="0" tIns="0" rIns="0" bIns="0" rtlCol="0" anchor="ctr"/>
           <a:lstStyle/>
           <a:p>
-            <a:pPr indent="0" marL="0">
+            <a:pPr marL="0" indent="0">
               <a:buNone/>
             </a:pPr>
             <a:r>
@@ -9153,6 +9446,13 @@
             <a:prstDash val="solid"/>
           </a:ln>
         </p:spPr>
+        <p:txBody>
+          <a:bodyPr/>
+          <a:lstStyle/>
+          <a:p>
+            <a:endParaRPr lang="en-US"/>
+          </a:p>
+        </p:txBody>
       </p:sp>
       <p:sp>
         <p:nvSpPr>
@@ -9178,6 +9478,13 @@
             <a:prstDash val="solid"/>
           </a:ln>
         </p:spPr>
+        <p:txBody>
+          <a:bodyPr/>
+          <a:lstStyle/>
+          <a:p>
+            <a:endParaRPr lang="en-US"/>
+          </a:p>
+        </p:txBody>
       </p:sp>
       <p:sp>
         <p:nvSpPr>
@@ -9200,7 +9507,7 @@
           <a:bodyPr wrap="square" lIns="0" tIns="0" rIns="0" bIns="0" rtlCol="0" anchor="ctr"/>
           <a:lstStyle/>
           <a:p>
-            <a:pPr algn="ctr" indent="0" marL="0">
+            <a:pPr marL="0" indent="0" algn="ctr">
               <a:buNone/>
             </a:pPr>
             <a:r>
@@ -9236,7 +9543,7 @@
           <a:bodyPr wrap="square" lIns="0" tIns="0" rIns="0" bIns="0" rtlCol="0" anchor="ctr"/>
           <a:lstStyle/>
           <a:p>
-            <a:pPr algn="ctr" indent="0" marL="0">
+            <a:pPr marL="0" indent="0" algn="ctr">
               <a:buNone/>
             </a:pPr>
             <a:r>
@@ -9431,6 +9738,13 @@
             <a:prstDash val="solid"/>
           </a:ln>
         </p:spPr>
+        <p:txBody>
+          <a:bodyPr/>
+          <a:lstStyle/>
+          <a:p>
+            <a:endParaRPr lang="en-US"/>
+          </a:p>
+        </p:txBody>
       </p:sp>
       <p:sp>
         <p:nvSpPr>
@@ -9458,6 +9772,13 @@
             <a:prstDash val="solid"/>
           </a:ln>
         </p:spPr>
+        <p:txBody>
+          <a:bodyPr/>
+          <a:lstStyle/>
+          <a:p>
+            <a:endParaRPr lang="en-US"/>
+          </a:p>
+        </p:txBody>
       </p:sp>
       <p:sp>
         <p:nvSpPr>
@@ -9480,7 +9801,7 @@
           <a:bodyPr wrap="square" lIns="0" tIns="0" rIns="0" bIns="0" rtlCol="0" anchor="ctr"/>
           <a:lstStyle/>
           <a:p>
-            <a:pPr algn="ctr" indent="0" marL="0">
+            <a:pPr marL="0" indent="0" algn="ctr">
               <a:buNone/>
             </a:pPr>
             <a:r>
@@ -9511,6 +9832,7 @@
         <a:solidFill>
           <a:srgbClr val="FFFFFF"/>
         </a:solidFill>
+        <a:effectLst/>
       </p:bgPr>
     </p:bg>
     <p:spTree>
@@ -9551,6 +9873,13 @@
             <a:prstDash val="solid"/>
           </a:ln>
         </p:spPr>
+        <p:txBody>
+          <a:bodyPr/>
+          <a:lstStyle/>
+          <a:p>
+            <a:endParaRPr lang="en-US"/>
+          </a:p>
+        </p:txBody>
       </p:sp>
       <p:sp>
         <p:nvSpPr>
@@ -9573,7 +9902,7 @@
           <a:bodyPr wrap="square" lIns="0" tIns="0" rIns="0" bIns="0" rtlCol="0" anchor="ctr"/>
           <a:lstStyle/>
           <a:p>
-            <a:pPr indent="0" marL="0">
+            <a:pPr marL="0" indent="0">
               <a:buNone/>
             </a:pPr>
             <a:r>
@@ -9612,7 +9941,7 @@
           <a:bodyPr wrap="square" lIns="0" tIns="0" rIns="0" bIns="0" rtlCol="0" anchor="ctr"/>
           <a:lstStyle/>
           <a:p>
-            <a:pPr algn="r" indent="0" marL="0">
+            <a:pPr marL="0" indent="0" algn="r">
               <a:buNone/>
             </a:pPr>
             <a:r>
@@ -9648,7 +9977,7 @@
           <a:bodyPr wrap="square" lIns="0" tIns="0" rIns="0" bIns="0" rtlCol="0" anchor="ctr"/>
           <a:lstStyle/>
           <a:p>
-            <a:pPr algn="r" indent="0" marL="0">
+            <a:pPr marL="0" indent="0" algn="r">
               <a:buNone/>
             </a:pPr>
             <a:r>
@@ -9684,7 +10013,7 @@
           <a:bodyPr wrap="square" lIns="0" tIns="0" rIns="0" bIns="0" rtlCol="0" anchor="ctr"/>
           <a:lstStyle/>
           <a:p>
-            <a:pPr indent="0" marL="0">
+            <a:pPr marL="0" indent="0">
               <a:buNone/>
             </a:pPr>
             <a:r>
@@ -9722,6 +10051,13 @@
             <a:tailEnd type="triangle"/>
           </a:ln>
         </p:spPr>
+        <p:txBody>
+          <a:bodyPr/>
+          <a:lstStyle/>
+          <a:p>
+            <a:endParaRPr lang="en-US"/>
+          </a:p>
+        </p:txBody>
       </p:sp>
       <p:sp>
         <p:nvSpPr>
@@ -9746,6 +10082,13 @@
             <a:tailEnd type="triangle"/>
           </a:ln>
         </p:spPr>
+        <p:txBody>
+          <a:bodyPr/>
+          <a:lstStyle/>
+          <a:p>
+            <a:endParaRPr lang="en-US"/>
+          </a:p>
+        </p:txBody>
       </p:sp>
       <p:sp>
         <p:nvSpPr>
@@ -9770,6 +10113,13 @@
             <a:tailEnd type="triangle"/>
           </a:ln>
         </p:spPr>
+        <p:txBody>
+          <a:bodyPr/>
+          <a:lstStyle/>
+          <a:p>
+            <a:endParaRPr lang="en-US"/>
+          </a:p>
+        </p:txBody>
       </p:sp>
       <p:sp>
         <p:nvSpPr>
@@ -9794,6 +10144,13 @@
             <a:tailEnd type="triangle"/>
           </a:ln>
         </p:spPr>
+        <p:txBody>
+          <a:bodyPr/>
+          <a:lstStyle/>
+          <a:p>
+            <a:endParaRPr lang="en-US"/>
+          </a:p>
+        </p:txBody>
       </p:sp>
       <p:sp>
         <p:nvSpPr>
@@ -9821,6 +10178,13 @@
             <a:prstDash val="solid"/>
           </a:ln>
         </p:spPr>
+        <p:txBody>
+          <a:bodyPr/>
+          <a:lstStyle/>
+          <a:p>
+            <a:endParaRPr lang="en-US"/>
+          </a:p>
+        </p:txBody>
       </p:sp>
       <p:sp>
         <p:nvSpPr>
@@ -9843,7 +10207,7 @@
           <a:bodyPr wrap="square" lIns="0" tIns="0" rIns="0" bIns="0" rtlCol="0" anchor="ctr"/>
           <a:lstStyle/>
           <a:p>
-            <a:pPr algn="ctr" indent="0" marL="0">
+            <a:pPr marL="0" indent="0" algn="ctr">
               <a:buNone/>
             </a:pPr>
             <a:r>
@@ -9881,7 +10245,7 @@
           </a:bodyPr>
           <a:lstStyle/>
           <a:p>
-            <a:pPr algn="ctr" indent="0" marL="0">
+            <a:pPr marL="0" indent="0" algn="ctr">
               <a:buNone/>
             </a:pPr>
             <a:r>
@@ -9895,7 +10259,7 @@
             <a:endParaRPr lang="en-US" sz="1050" dirty="0"/>
           </a:p>
           <a:p>
-            <a:pPr algn="ctr" indent="0" marL="0">
+            <a:pPr marL="0" indent="0" algn="ctr">
               <a:buNone/>
             </a:pPr>
             <a:r>
@@ -9936,6 +10300,13 @@
             <a:prstDash val="solid"/>
           </a:ln>
         </p:spPr>
+        <p:txBody>
+          <a:bodyPr/>
+          <a:lstStyle/>
+          <a:p>
+            <a:endParaRPr lang="en-US"/>
+          </a:p>
+        </p:txBody>
       </p:sp>
       <p:sp>
         <p:nvSpPr>
@@ -9958,7 +10329,7 @@
           <a:bodyPr wrap="square" lIns="0" tIns="0" rIns="0" bIns="0" rtlCol="0" anchor="ctr"/>
           <a:lstStyle/>
           <a:p>
-            <a:pPr algn="ctr" indent="0" marL="0">
+            <a:pPr marL="0" indent="0" algn="ctr">
               <a:buNone/>
             </a:pPr>
             <a:r>
@@ -9996,7 +10367,7 @@
           </a:bodyPr>
           <a:lstStyle/>
           <a:p>
-            <a:pPr algn="ctr" indent="0" marL="0">
+            <a:pPr marL="0" indent="0" algn="ctr">
               <a:buNone/>
             </a:pPr>
             <a:r>
@@ -10010,7 +10381,7 @@
             <a:endParaRPr lang="en-US" sz="1050" dirty="0"/>
           </a:p>
           <a:p>
-            <a:pPr algn="ctr" indent="0" marL="0">
+            <a:pPr marL="0" indent="0" algn="ctr">
               <a:buNone/>
             </a:pPr>
             <a:r>
@@ -10051,6 +10422,13 @@
             <a:prstDash val="solid"/>
           </a:ln>
         </p:spPr>
+        <p:txBody>
+          <a:bodyPr/>
+          <a:lstStyle/>
+          <a:p>
+            <a:endParaRPr lang="en-US"/>
+          </a:p>
+        </p:txBody>
       </p:sp>
       <p:sp>
         <p:nvSpPr>
@@ -10073,7 +10451,7 @@
           <a:bodyPr wrap="square" lIns="0" tIns="0" rIns="0" bIns="0" rtlCol="0" anchor="ctr"/>
           <a:lstStyle/>
           <a:p>
-            <a:pPr algn="ctr" indent="0" marL="0">
+            <a:pPr marL="0" indent="0" algn="ctr">
               <a:buNone/>
             </a:pPr>
             <a:r>
@@ -10111,7 +10489,7 @@
           </a:bodyPr>
           <a:lstStyle/>
           <a:p>
-            <a:pPr algn="ctr" indent="0" marL="0">
+            <a:pPr marL="0" indent="0" algn="ctr">
               <a:buNone/>
             </a:pPr>
             <a:r>
@@ -10125,7 +10503,7 @@
             <a:endParaRPr lang="en-US" sz="1050" dirty="0"/>
           </a:p>
           <a:p>
-            <a:pPr algn="ctr" indent="0" marL="0">
+            <a:pPr marL="0" indent="0" algn="ctr">
               <a:buNone/>
             </a:pPr>
             <a:r>
@@ -10166,6 +10544,13 @@
             <a:prstDash val="solid"/>
           </a:ln>
         </p:spPr>
+        <p:txBody>
+          <a:bodyPr/>
+          <a:lstStyle/>
+          <a:p>
+            <a:endParaRPr lang="en-US"/>
+          </a:p>
+        </p:txBody>
       </p:sp>
       <p:sp>
         <p:nvSpPr>
@@ -10188,7 +10573,7 @@
           <a:bodyPr wrap="square" lIns="0" tIns="0" rIns="0" bIns="0" rtlCol="0" anchor="ctr"/>
           <a:lstStyle/>
           <a:p>
-            <a:pPr algn="ctr" indent="0" marL="0">
+            <a:pPr marL="0" indent="0" algn="ctr">
               <a:buNone/>
             </a:pPr>
             <a:r>
@@ -10226,7 +10611,7 @@
           </a:bodyPr>
           <a:lstStyle/>
           <a:p>
-            <a:pPr algn="ctr" indent="0" marL="0">
+            <a:pPr marL="0" indent="0" algn="ctr">
               <a:buNone/>
             </a:pPr>
             <a:r>
@@ -10240,7 +10625,7 @@
             <a:endParaRPr lang="en-US" sz="1050" dirty="0"/>
           </a:p>
           <a:p>
-            <a:pPr algn="ctr" indent="0" marL="0">
+            <a:pPr marL="0" indent="0" algn="ctr">
               <a:buNone/>
             </a:pPr>
             <a:r>
@@ -10281,6 +10666,13 @@
             <a:prstDash val="solid"/>
           </a:ln>
         </p:spPr>
+        <p:txBody>
+          <a:bodyPr/>
+          <a:lstStyle/>
+          <a:p>
+            <a:endParaRPr lang="en-US"/>
+          </a:p>
+        </p:txBody>
       </p:sp>
       <p:sp>
         <p:nvSpPr>
@@ -10303,7 +10695,7 @@
           <a:bodyPr wrap="square" lIns="0" tIns="0" rIns="0" bIns="0" rtlCol="0" anchor="ctr"/>
           <a:lstStyle/>
           <a:p>
-            <a:pPr algn="ctr" indent="0" marL="0">
+            <a:pPr marL="0" indent="0" algn="ctr">
               <a:buNone/>
             </a:pPr>
             <a:r>
@@ -10341,7 +10733,7 @@
           </a:bodyPr>
           <a:lstStyle/>
           <a:p>
-            <a:pPr algn="ctr" indent="0" marL="0">
+            <a:pPr marL="0" indent="0" algn="ctr">
               <a:buNone/>
             </a:pPr>
             <a:r>
@@ -10355,7 +10747,7 @@
             <a:endParaRPr lang="en-US" sz="1050" dirty="0"/>
           </a:p>
           <a:p>
-            <a:pPr algn="ctr" indent="0" marL="0">
+            <a:pPr marL="0" indent="0" algn="ctr">
               <a:buNone/>
             </a:pPr>
             <a:r>
@@ -10391,7 +10783,7 @@
           <a:bodyPr wrap="square" lIns="0" tIns="0" rIns="0" bIns="0" rtlCol="0" anchor="ctr"/>
           <a:lstStyle/>
           <a:p>
-            <a:pPr indent="0" marL="0">
+            <a:pPr marL="0" indent="0">
               <a:buNone/>
             </a:pPr>
             <a:r>
@@ -10489,6 +10881,13 @@
             <a:prstDash val="solid"/>
           </a:ln>
         </p:spPr>
+        <p:txBody>
+          <a:bodyPr/>
+          <a:lstStyle/>
+          <a:p>
+            <a:endParaRPr lang="en-US"/>
+          </a:p>
+        </p:txBody>
       </p:sp>
       <p:sp>
         <p:nvSpPr>
@@ -10511,7 +10910,7 @@
           <a:bodyPr wrap="square" lIns="0" tIns="0" rIns="0" bIns="0" rtlCol="0" anchor="ctr"/>
           <a:lstStyle/>
           <a:p>
-            <a:pPr algn="ctr" indent="0" marL="0">
+            <a:pPr marL="0" indent="0" algn="ctr">
               <a:buNone/>
             </a:pPr>
             <a:r>
@@ -10827,4 +11226,319 @@
     </a:ext>
   </a:extLst>
 </a:theme>
+</file>
+
+<file path=ppt/theme/theme2.xml><?xml version="1.0" encoding="utf-8"?>
+<a:theme xmlns:a="http://schemas.openxmlformats.org/drawingml/2006/main" name="Office Theme">
+  <a:themeElements>
+    <a:clrScheme name="Office">
+      <a:dk1>
+        <a:sysClr val="windowText" lastClr="000000"/>
+      </a:dk1>
+      <a:lt1>
+        <a:sysClr val="window" lastClr="FFFFFF"/>
+      </a:lt1>
+      <a:dk2>
+        <a:srgbClr val="0E2841"/>
+      </a:dk2>
+      <a:lt2>
+        <a:srgbClr val="E8E8E8"/>
+      </a:lt2>
+      <a:accent1>
+        <a:srgbClr val="156082"/>
+      </a:accent1>
+      <a:accent2>
+        <a:srgbClr val="E97132"/>
+      </a:accent2>
+      <a:accent3>
+        <a:srgbClr val="196B24"/>
+      </a:accent3>
+      <a:accent4>
+        <a:srgbClr val="0F9ED5"/>
+      </a:accent4>
+      <a:accent5>
+        <a:srgbClr val="A02B93"/>
+      </a:accent5>
+      <a:accent6>
+        <a:srgbClr val="4EA72E"/>
+      </a:accent6>
+      <a:hlink>
+        <a:srgbClr val="467886"/>
+      </a:hlink>
+      <a:folHlink>
+        <a:srgbClr val="96607D"/>
+      </a:folHlink>
+    </a:clrScheme>
+    <a:fontScheme name="Office">
+      <a:majorFont>
+        <a:latin typeface="Aptos Display" panose="02110004020202020204"/>
+        <a:ea typeface=""/>
+        <a:cs typeface=""/>
+        <a:font script="Jpan" typeface="游ゴシック Light"/>
+        <a:font script="Hang" typeface="맑은 고딕"/>
+        <a:font script="Hans" typeface="等线 Light"/>
+        <a:font script="Hant" typeface="新細明體"/>
+        <a:font script="Arab" typeface="Times New Roman"/>
+        <a:font script="Hebr" typeface="Times New Roman"/>
+        <a:font script="Thai" typeface="Angsana New"/>
+        <a:font script="Ethi" typeface="Nyala"/>
+        <a:font script="Beng" typeface="Vrinda"/>
+        <a:font script="Gujr" typeface="Shruti"/>
+        <a:font script="Khmr" typeface="MoolBoran"/>
+        <a:font script="Knda" typeface="Tunga"/>
+        <a:font script="Guru" typeface="Raavi"/>
+        <a:font script="Cans" typeface="Euphemia"/>
+        <a:font script="Cher" typeface="Plantagenet Cherokee"/>
+        <a:font script="Yiii" typeface="Microsoft Yi Baiti"/>
+        <a:font script="Tibt" typeface="Microsoft Himalaya"/>
+        <a:font script="Thaa" typeface="MV Boli"/>
+        <a:font script="Deva" typeface="Mangal"/>
+        <a:font script="Telu" typeface="Gautami"/>
+        <a:font script="Taml" typeface="Latha"/>
+        <a:font script="Syrc" typeface="Estrangelo Edessa"/>
+        <a:font script="Orya" typeface="Kalinga"/>
+        <a:font script="Mlym" typeface="Kartika"/>
+        <a:font script="Laoo" typeface="DokChampa"/>
+        <a:font script="Sinh" typeface="Iskoola Pota"/>
+        <a:font script="Mong" typeface="Mongolian Baiti"/>
+        <a:font script="Viet" typeface="Times New Roman"/>
+        <a:font script="Uigh" typeface="Microsoft Uighur"/>
+        <a:font script="Geor" typeface="Sylfaen"/>
+        <a:font script="Armn" typeface="Arial"/>
+        <a:font script="Bugi" typeface="Leelawadee UI"/>
+        <a:font script="Bopo" typeface="Microsoft JhengHei"/>
+        <a:font script="Java" typeface="Javanese Text"/>
+        <a:font script="Lisu" typeface="Segoe UI"/>
+        <a:font script="Mymr" typeface="Myanmar Text"/>
+        <a:font script="Nkoo" typeface="Ebrima"/>
+        <a:font script="Olck" typeface="Nirmala UI"/>
+        <a:font script="Osma" typeface="Ebrima"/>
+        <a:font script="Phag" typeface="Phagspa"/>
+        <a:font script="Syrn" typeface="Estrangelo Edessa"/>
+        <a:font script="Syrj" typeface="Estrangelo Edessa"/>
+        <a:font script="Syre" typeface="Estrangelo Edessa"/>
+        <a:font script="Sora" typeface="Nirmala UI"/>
+        <a:font script="Tale" typeface="Microsoft Tai Le"/>
+        <a:font script="Talu" typeface="Microsoft New Tai Lue"/>
+        <a:font script="Tfng" typeface="Ebrima"/>
+      </a:majorFont>
+      <a:minorFont>
+        <a:latin typeface="Aptos" panose="02110004020202020204"/>
+        <a:ea typeface=""/>
+        <a:cs typeface=""/>
+        <a:font script="Jpan" typeface="游ゴシック"/>
+        <a:font script="Hang" typeface="맑은 고딕"/>
+        <a:font script="Hans" typeface="等线"/>
+        <a:font script="Hant" typeface="新細明體"/>
+        <a:font script="Arab" typeface="Arial"/>
+        <a:font script="Hebr" typeface="Arial"/>
+        <a:font script="Thai" typeface="Cordia New"/>
+        <a:font script="Ethi" typeface="Nyala"/>
+        <a:font script="Beng" typeface="Vrinda"/>
+        <a:font script="Gujr" typeface="Shruti"/>
+        <a:font script="Khmr" typeface="DaunPenh"/>
+        <a:font script="Knda" typeface="Tunga"/>
+        <a:font script="Guru" typeface="Raavi"/>
+        <a:font script="Cans" typeface="Euphemia"/>
+        <a:font script="Cher" typeface="Plantagenet Cherokee"/>
+        <a:font script="Yiii" typeface="Microsoft Yi Baiti"/>
+        <a:font script="Tibt" typeface="Microsoft Himalaya"/>
+        <a:font script="Thaa" typeface="MV Boli"/>
+        <a:font script="Deva" typeface="Mangal"/>
+        <a:font script="Telu" typeface="Gautami"/>
+        <a:font script="Taml" typeface="Latha"/>
+        <a:font script="Syrc" typeface="Estrangelo Edessa"/>
+        <a:font script="Orya" typeface="Kalinga"/>
+        <a:font script="Mlym" typeface="Kartika"/>
+        <a:font script="Laoo" typeface="DokChampa"/>
+        <a:font script="Sinh" typeface="Iskoola Pota"/>
+        <a:font script="Mong" typeface="Mongolian Baiti"/>
+        <a:font script="Viet" typeface="Arial"/>
+        <a:font script="Uigh" typeface="Microsoft Uighur"/>
+        <a:font script="Geor" typeface="Sylfaen"/>
+        <a:font script="Armn" typeface="Arial"/>
+        <a:font script="Bugi" typeface="Leelawadee UI"/>
+        <a:font script="Bopo" typeface="Microsoft JhengHei"/>
+        <a:font script="Java" typeface="Javanese Text"/>
+        <a:font script="Lisu" typeface="Segoe UI"/>
+        <a:font script="Mymr" typeface="Myanmar Text"/>
+        <a:font script="Nkoo" typeface="Ebrima"/>
+        <a:font script="Olck" typeface="Nirmala UI"/>
+        <a:font script="Osma" typeface="Ebrima"/>
+        <a:font script="Phag" typeface="Phagspa"/>
+        <a:font script="Syrn" typeface="Estrangelo Edessa"/>
+        <a:font script="Syrj" typeface="Estrangelo Edessa"/>
+        <a:font script="Syre" typeface="Estrangelo Edessa"/>
+        <a:font script="Sora" typeface="Nirmala UI"/>
+        <a:font script="Tale" typeface="Microsoft Tai Le"/>
+        <a:font script="Talu" typeface="Microsoft New Tai Lue"/>
+        <a:font script="Tfng" typeface="Ebrima"/>
+      </a:minorFont>
+    </a:fontScheme>
+    <a:fmtScheme name="Office">
+      <a:fillStyleLst>
+        <a:solidFill>
+          <a:schemeClr val="phClr"/>
+        </a:solidFill>
+        <a:gradFill rotWithShape="1">
+          <a:gsLst>
+            <a:gs pos="0">
+              <a:schemeClr val="phClr">
+                <a:lumMod val="110000"/>
+                <a:satMod val="105000"/>
+                <a:tint val="67000"/>
+              </a:schemeClr>
+            </a:gs>
+            <a:gs pos="50000">
+              <a:schemeClr val="phClr">
+                <a:lumMod val="105000"/>
+                <a:satMod val="103000"/>
+                <a:tint val="73000"/>
+              </a:schemeClr>
+            </a:gs>
+            <a:gs pos="100000">
+              <a:schemeClr val="phClr">
+                <a:lumMod val="105000"/>
+                <a:satMod val="109000"/>
+                <a:tint val="81000"/>
+              </a:schemeClr>
+            </a:gs>
+          </a:gsLst>
+          <a:lin ang="5400000" scaled="0"/>
+        </a:gradFill>
+        <a:gradFill rotWithShape="1">
+          <a:gsLst>
+            <a:gs pos="0">
+              <a:schemeClr val="phClr">
+                <a:satMod val="103000"/>
+                <a:lumMod val="102000"/>
+                <a:tint val="94000"/>
+              </a:schemeClr>
+            </a:gs>
+            <a:gs pos="50000">
+              <a:schemeClr val="phClr">
+                <a:satMod val="110000"/>
+                <a:lumMod val="100000"/>
+                <a:shade val="100000"/>
+              </a:schemeClr>
+            </a:gs>
+            <a:gs pos="100000">
+              <a:schemeClr val="phClr">
+                <a:lumMod val="99000"/>
+                <a:satMod val="120000"/>
+                <a:shade val="78000"/>
+              </a:schemeClr>
+            </a:gs>
+          </a:gsLst>
+          <a:lin ang="5400000" scaled="0"/>
+        </a:gradFill>
+      </a:fillStyleLst>
+      <a:lnStyleLst>
+        <a:ln w="12700" cap="flat" cmpd="sng" algn="ctr">
+          <a:solidFill>
+            <a:schemeClr val="phClr"/>
+          </a:solidFill>
+          <a:prstDash val="solid"/>
+          <a:miter lim="800000"/>
+        </a:ln>
+        <a:ln w="19050" cap="flat" cmpd="sng" algn="ctr">
+          <a:solidFill>
+            <a:schemeClr val="phClr"/>
+          </a:solidFill>
+          <a:prstDash val="solid"/>
+          <a:miter lim="800000"/>
+        </a:ln>
+        <a:ln w="25400" cap="flat" cmpd="sng" algn="ctr">
+          <a:solidFill>
+            <a:schemeClr val="phClr"/>
+          </a:solidFill>
+          <a:prstDash val="solid"/>
+          <a:miter lim="800000"/>
+        </a:ln>
+      </a:lnStyleLst>
+      <a:effectStyleLst>
+        <a:effectStyle>
+          <a:effectLst/>
+        </a:effectStyle>
+        <a:effectStyle>
+          <a:effectLst/>
+        </a:effectStyle>
+        <a:effectStyle>
+          <a:effectLst>
+            <a:outerShdw blurRad="57150" dist="19050" dir="5400000" algn="ctr" rotWithShape="0">
+              <a:srgbClr val="000000">
+                <a:alpha val="63000"/>
+              </a:srgbClr>
+            </a:outerShdw>
+          </a:effectLst>
+        </a:effectStyle>
+      </a:effectStyleLst>
+      <a:bgFillStyleLst>
+        <a:solidFill>
+          <a:schemeClr val="phClr"/>
+        </a:solidFill>
+        <a:solidFill>
+          <a:schemeClr val="phClr">
+            <a:tint val="95000"/>
+            <a:satMod val="170000"/>
+          </a:schemeClr>
+        </a:solidFill>
+        <a:gradFill rotWithShape="1">
+          <a:gsLst>
+            <a:gs pos="0">
+              <a:schemeClr val="phClr">
+                <a:tint val="93000"/>
+                <a:satMod val="150000"/>
+                <a:shade val="98000"/>
+                <a:lumMod val="102000"/>
+              </a:schemeClr>
+            </a:gs>
+            <a:gs pos="50000">
+              <a:schemeClr val="phClr">
+                <a:tint val="98000"/>
+                <a:satMod val="130000"/>
+                <a:shade val="90000"/>
+                <a:lumMod val="103000"/>
+              </a:schemeClr>
+            </a:gs>
+            <a:gs pos="100000">
+              <a:schemeClr val="phClr">
+                <a:shade val="63000"/>
+                <a:satMod val="120000"/>
+              </a:schemeClr>
+            </a:gs>
+          </a:gsLst>
+          <a:lin ang="5400000" scaled="0"/>
+        </a:gradFill>
+      </a:bgFillStyleLst>
+    </a:fmtScheme>
+  </a:themeElements>
+  <a:objectDefaults>
+    <a:lnDef>
+      <a:spPr/>
+      <a:bodyPr/>
+      <a:lstStyle/>
+      <a:style>
+        <a:lnRef idx="2">
+          <a:schemeClr val="accent1"/>
+        </a:lnRef>
+        <a:fillRef idx="0">
+          <a:schemeClr val="accent1"/>
+        </a:fillRef>
+        <a:effectRef idx="1">
+          <a:schemeClr val="accent1"/>
+        </a:effectRef>
+        <a:fontRef idx="minor">
+          <a:schemeClr val="tx1"/>
+        </a:fontRef>
+      </a:style>
+    </a:lnDef>
+  </a:objectDefaults>
+  <a:extraClrSchemeLst/>
+  <a:extLst>
+    <a:ext uri="{05A4C25C-085E-4340-85A3-A5531E510DB2}">
+      <thm15:themeFamily xmlns:thm15="http://schemas.microsoft.com/office/thememl/2012/main" name="Office Theme" id="{2E142A2C-CD16-42D6-873A-C26D2A0506FA}" vid="{1BDDFF52-6CD6-40A5-AB3C-68EB2F1E4D0A}"/>
+    </a:ext>
+  </a:extLst>
+</a:theme>
 </file>
</xml_diff>